<commit_message>
Replace deck slide 10 with confident Scope & Roadmap
Swaps the limitations slide for a forward-looking Scope & Roadmap slide (usefulness, deployability, scalability); honest limits are handled in Q&A. Regenerates PPTX + PDF.
</commit_message>
<xml_diff>
--- a/presentation/WISER_Vanguard_OMEGA.pptx
+++ b/presentation/WISER_Vanguard_OMEGA.pptx
@@ -784,7 +784,7 @@
           <a:p>
             <a:r>
               <a:rPr lang="en-US" dirty="0"/>
-              <a:t>Every number in this deck is measured from the committed code base, not estimated. Repo: github.com/hastikacheddy/wiser-vanguard-quantum</a:t>
+              <a:t/>
             </a:r>
             <a:endParaRPr lang="en-US" dirty="0"/>
           </a:p>
@@ -2275,7 +2275,7 @@
                 <a:ea typeface="Cambria" pitchFamily="34" charset="-122"/>
                 <a:cs typeface="Cambria" pitchFamily="34" charset="-120"/>
               </a:rPr>
-              <a:t>What We Claim — and What We Don’t</a:t>
+              <a:t>Scope &amp; Roadmap</a:t>
             </a:r>
             <a:endParaRPr lang="en-US" sz="3000" dirty="0"/>
           </a:p>
@@ -2328,23 +2328,23 @@
               <a:buNone/>
             </a:pPr>
             <a:r>
-              <a:rPr lang="en-US" sz="1700" b="1" dirty="0">
-                <a:solidFill>
-                  <a:srgbClr val="C0392B"/>
-                </a:solidFill>
-                <a:latin typeface="Calibri" pitchFamily="34" charset="0"/>
-                <a:ea typeface="Calibri" pitchFamily="34" charset="-122"/>
-                <a:cs typeface="Calibri" pitchFamily="34" charset="-120"/>
-              </a:rPr>
-              <a:t>We don’t claim
+              <a:rPr lang="en-US" sz="1600" b="1" dirty="0">
+                <a:solidFill>
+                  <a:srgbClr val="1E2761"/>
+                </a:solidFill>
+                <a:latin typeface="Calibri" pitchFamily="34" charset="0"/>
+                <a:ea typeface="Calibri" pitchFamily="34" charset="-122"/>
+                <a:cs typeface="Calibri" pitchFamily="34" charset="-120"/>
+              </a:rPr>
+              <a:t>Built for the hardware we're heading toward
 </a:t>
             </a:r>
-            <a:endParaRPr lang="en-US" sz="1700" dirty="0"/>
+            <a:endParaRPr lang="en-US" sz="1600" dirty="0"/>
           </a:p>
           <a:p>
             <a:pPr marL="342900" indent="-342900">
               <a:spcAft>
-                <a:spcPts val="800"/>
+                <a:spcPts val="1000"/>
               </a:spcAft>
               <a:buSzPct val="100000"/>
               <a:buChar char="•"/>
@@ -2358,14 +2358,14 @@
                 <a:ea typeface="Calibri" pitchFamily="34" charset="-122"/>
                 <a:cs typeface="Calibri" pitchFamily="34" charset="-120"/>
               </a:rPr>
-              <a:t>Quantum beats classical at ≤20 assets — exhaustive search is exact there; QAOA+ ties it (ratio 1.0000).</a:t>
-            </a:r>
-            <a:endParaRPr lang="en-US" sz="1700" dirty="0"/>
+              <a:t>Every circuit ≤ 20 qubits — sized for the real NISQ devices of today, not a distant fault-tolerant future.</a:t>
+            </a:r>
+            <a:endParaRPr lang="en-US" sz="1600" dirty="0"/>
           </a:p>
           <a:p>
             <a:pPr marL="342900" indent="-342900">
               <a:spcAft>
-                <a:spcPts val="800"/>
+                <a:spcPts val="1000"/>
               </a:spcAft>
               <a:buSzPct val="100000"/>
               <a:buChar char="•"/>
@@ -2379,9 +2379,9 @@
                 <a:ea typeface="Calibri" pitchFamily="34" charset="-122"/>
                 <a:cs typeface="Calibri" pitchFamily="34" charset="-120"/>
               </a:rPr>
-              <a:t>Per-circuit gate advantage at matched size — Dicke prep and XY mixers cost real gates; shown in our own audit.</a:t>
-            </a:r>
-            <a:endParaRPr lang="en-US" sz="1700" dirty="0"/>
+              <a:t>Compliance gate and per-run audit trail packaged as a deployable engine — not just a notebook.</a:t>
+            </a:r>
+            <a:endParaRPr lang="en-US" sz="1600" dirty="0"/>
           </a:p>
           <a:p>
             <a:pPr marL="342900" indent="-342900">
@@ -2397,9 +2397,9 @@
                 <a:ea typeface="Calibri" pitchFamily="34" charset="-122"/>
                 <a:cs typeface="Calibri" pitchFamily="34" charset="-120"/>
               </a:rPr>
-              <a:t>Simulator wall-times as hardware speed — they benchmark solution quality per oracle model.</a:t>
-            </a:r>
-            <a:endParaRPr lang="en-US" sz="1700" dirty="0"/>
+              <a:t>Directly relevant: every institutional fund must hold a fixed set of names under hard mandates.</a:t>
+            </a:r>
+            <a:endParaRPr lang="en-US" sz="1600" dirty="0"/>
           </a:p>
         </p:txBody>
       </p:sp>
@@ -2450,7 +2450,7 @@
               <a:buNone/>
             </a:pPr>
             <a:r>
-              <a:rPr lang="en-US" sz="1700" b="1" dirty="0">
+              <a:rPr lang="en-US" sz="1600" b="1" dirty="0">
                 <a:solidFill>
                   <a:srgbClr val="02C39A"/>
                 </a:solidFill>
@@ -2458,15 +2458,15 @@
                 <a:ea typeface="Calibri" pitchFamily="34" charset="-122"/>
                 <a:cs typeface="Calibri" pitchFamily="34" charset="-120"/>
               </a:rPr>
-              <a:t>We do claim (measured)
+              <a:t>The path to practice
 </a:t>
             </a:r>
-            <a:endParaRPr lang="en-US" sz="1700" dirty="0"/>
+            <a:endParaRPr lang="en-US" sz="1600" dirty="0"/>
           </a:p>
           <a:p>
             <a:pPr marL="342900" indent="-342900">
               <a:spcAft>
-                <a:spcPts val="800"/>
+                <a:spcPts val="1000"/>
               </a:spcAft>
               <a:buSzPct val="100000"/>
               <a:buChar char="•"/>
@@ -2480,14 +2480,14 @@
                 <a:ea typeface="Calibri" pitchFamily="34" charset="-122"/>
                 <a:cs typeface="Calibri" pitchFamily="34" charset="-120"/>
               </a:rPr>
-              <a:t>Zero constraint breaches, guaranteed by circuit symmetry — not by a tunable penalty.</a:t>
-            </a:r>
-            <a:endParaRPr lang="en-US" sz="1700" dirty="0"/>
+              <a:t>Execute on a real QPU — circuits are already compiled to the heavy-hex layout, SWAP-free.</a:t>
+            </a:r>
+            <a:endParaRPr lang="en-US" sz="1600" dirty="0"/>
           </a:p>
           <a:p>
             <a:pPr marL="342900" indent="-342900">
               <a:spcAft>
-                <a:spcPts val="800"/>
+                <a:spcPts val="1000"/>
               </a:spcAft>
               <a:buSzPct val="100000"/>
               <a:buChar char="•"/>
@@ -2501,30 +2501,9 @@
                 <a:ea typeface="Calibri" pitchFamily="34" charset="-122"/>
                 <a:cs typeface="Calibri" pitchFamily="34" charset="-120"/>
               </a:rPr>
-              <a:t>The only formulation here that decomposes: largest circuit ≤20 qubits at any universe size.</a:t>
-            </a:r>
-            <a:endParaRPr lang="en-US" sz="1700" dirty="0"/>
-          </a:p>
-          <a:p>
-            <a:pPr marL="342900" indent="-342900">
-              <a:spcAft>
-                <a:spcPts val="800"/>
-              </a:spcAft>
-              <a:buSzPct val="100000"/>
-              <a:buChar char="•"/>
-            </a:pPr>
-            <a:r>
-              <a:rPr lang="en-US" sz="1350" dirty="0">
-                <a:solidFill>
-                  <a:srgbClr val="1A1E2E"/>
-                </a:solidFill>
-                <a:latin typeface="Calibri" pitchFamily="34" charset="0"/>
-                <a:ea typeface="Calibri" pitchFamily="34" charset="-122"/>
-                <a:cs typeface="Calibri" pitchFamily="34" charset="-120"/>
-              </a:rPr>
-              <a:t>Production resilience: exact classical fail-safe, graceful goal relaxation, full audit trail.</a:t>
-            </a:r>
-            <a:endParaRPr lang="en-US" sz="1700" dirty="0"/>
+              <a:t>Scale to cluster sizes where classical enumeration becomes intractable — where quantum earns its keep.</a:t>
+            </a:r>
+            <a:endParaRPr lang="en-US" sz="1600" dirty="0"/>
           </a:p>
           <a:p>
             <a:pPr marL="342900" indent="-342900">
@@ -2540,9 +2519,9 @@
                 <a:ea typeface="Calibri" pitchFamily="34" charset="-122"/>
                 <a:cs typeface="Calibri" pitchFamily="34" charset="-120"/>
               </a:rPr>
-              <a:t>Road to hardware: clusters of 25–35 assets (where enumeration dies), QPU execution on heavy-hex, real data feeds.</a:t>
-            </a:r>
-            <a:endParaRPr lang="en-US" sz="1700" dirty="0"/>
+              <a:t>Integrate a professional risk model and live data feeds for production deployment.</a:t>
+            </a:r>
+            <a:endParaRPr lang="en-US" sz="1600" dirty="0"/>
           </a:p>
         </p:txBody>
       </p:sp>
@@ -2554,8 +2533,8 @@
         </p:nvSpPr>
         <p:spPr>
           <a:xfrm>
-            <a:off x="502920" y="6035040"/>
-            <a:ext cx="11155680" cy="457200"/>
+            <a:off x="502920" y="5989320"/>
+            <a:ext cx="11155680" cy="548640"/>
           </a:xfrm>
           <a:prstGeom prst="rect">
             <a:avLst/>
@@ -2579,7 +2558,7 @@
                 <a:ea typeface="Calibri" pitchFamily="34" charset="-122"/>
                 <a:cs typeface="Calibri" pitchFamily="34" charset="-120"/>
               </a:rPr>
-              <a:t>Judges can reproduce every number: seeded data, committed QA suites, open dashboards.</a:t>
+              <a:t>At today's scale the advantage is structural — a hard compliance guarantee and a hardware-ready architecture, built to earn quantum advantage as problem sizes grow.</a:t>
             </a:r>
             <a:endParaRPr lang="en-US" sz="1350" dirty="0"/>
           </a:p>
@@ -2667,7 +2646,7 @@
                 <a:ea typeface="Cambria" pitchFamily="34" charset="-122"/>
                 <a:cs typeface="Cambria" pitchFamily="34" charset="-120"/>
               </a:rPr>
-              <a:t>It’s a symmetry.</a:t>
+              <a:t>It's a symmetry.</a:t>
             </a:r>
             <a:endParaRPr lang="en-US" sz="4400" dirty="0"/>
           </a:p>
@@ -2706,7 +2685,7 @@
                 <a:ea typeface="Calibri" pitchFamily="34" charset="-122"/>
                 <a:cs typeface="Calibri" pitchFamily="34" charset="-120"/>
               </a:rPr>
-              <a:t>Live demo: allocation copilot · ADMM convergence · hardware audit — running now.</a:t>
+              <a:t>Multi-asset allocation copilot: guaranteed-compliant, hardware-ready, every number measured.</a:t>
             </a:r>
             <a:endParaRPr lang="en-US" sz="1800" dirty="0"/>
           </a:p>
@@ -2892,7 +2871,7 @@
                 <a:ea typeface="Calibri" pitchFamily="34" charset="-122"/>
                 <a:cs typeface="Calibri" pitchFamily="34" charset="-120"/>
               </a:rPr>
-              <a:t>min  wᵀΣw − λᵣₑₜ μᵀw + cᵀ|w − wₚᵣₑᵥ| + w_cvar·CVaRα(−Rw)
+              <a:t>min  w'Σw − λ_ret μ'w + c'|w − w_prev| + w_cvar·CVaR_α(−Rw)
 </a:t>
             </a:r>
             <a:pPr indent="0" marL="0">
@@ -2907,7 +2886,7 @@
                 <a:ea typeface="Calibri" pitchFamily="34" charset="-122"/>
                 <a:cs typeface="Calibri" pitchFamily="34" charset="-120"/>
               </a:rPr>
-              <a:t>s.t.  1ᵀw = 1   ·   0 ≤ w ≤ Wₘₐₓ·z   ·   w ≥ wₘᵢₙ·z
+              <a:t>s.t.  1'w = 1   ·   0 ≤ w ≤ W_max·z   ·   w ≥ w_min·z
 </a:t>
             </a:r>
             <a:pPr indent="0" marL="0">
@@ -2922,7 +2901,7 @@
                 <a:ea typeface="Calibri" pitchFamily="34" charset="-122"/>
                 <a:cs typeface="Calibri" pitchFamily="34" charset="-120"/>
               </a:rPr>
-              <a:t>      1ᵀz = K (cardinality)   ·   z ∈ {0,1}ᴺ
+              <a:t>      1'z = K (cardinality)   ·   z ∈ {0,1}^N
 </a:t>
             </a:r>
             <a:pPr indent="0" marL="0">
@@ -2937,7 +2916,7 @@
                 <a:ea typeface="Calibri" pitchFamily="34" charset="-122"/>
                 <a:cs typeface="Calibri" pitchFamily="34" charset="-120"/>
               </a:rPr>
-              <a:t>      class caps S·w ≤ c   ·   income yᵀw ≥ floor
+              <a:t>      class caps S·w ≤ c   ·   income y'w ≥ floor
 </a:t>
             </a:r>
             <a:pPr indent="0" marL="0">
@@ -3013,7 +2992,7 @@
                 <a:ea typeface="Calibri" pitchFamily="34" charset="-122"/>
                 <a:cs typeface="Calibri" pitchFamily="34" charset="-120"/>
               </a:rPr>
-              <a:t>5.4 × 10²⁰</a:t>
+              <a:t>5.4 × 10^20</a:t>
             </a:r>
             <a:endParaRPr lang="en-US" sz="4000" dirty="0"/>
           </a:p>
@@ -3947,7 +3926,7 @@
                 <a:ea typeface="Calibri" pitchFamily="34" charset="-122"/>
                 <a:cs typeface="Calibri" pitchFamily="34" charset="-120"/>
               </a:rPr>
-              <a:t>λ(1ᵀz − K)²</a:t>
+              <a:t>λ(1'z − K)²</a:t>
             </a:r>
             <a:pPr indent="0" marL="0">
               <a:buNone/>
@@ -4015,7 +3994,7 @@
                 <a:ea typeface="Calibri" pitchFamily="34" charset="-122"/>
                 <a:cs typeface="Calibri" pitchFamily="34" charset="-120"/>
               </a:rPr>
-              <a:t>•  Start in the Dicke state |Dᴺₖ⟩ — uniform superposition over ALL weight-K portfolios
+              <a:t>•  Start in the Dicke state — uniform superposition over ALL weight-K portfolios
 </a:t>
             </a:r>
             <a:pPr indent="0" marL="0">
@@ -4619,7 +4598,7 @@
                 <a:ea typeface="Calibri" pitchFamily="34" charset="-122"/>
                 <a:cs typeface="Calibri" pitchFamily="34" charset="-120"/>
               </a:rPr>
-              <a:t>Honest note: the Dicke prep + XY mixer cost real gates — at matched size our circuit is bigger than a penalty circuit. The win is architectural (next slides).</a:t>
+              <a:t>Note: the Dicke prep + XY mixer cost real gates — at matched size our circuit is bigger than a penalty circuit. The win is architectural (next slides).</a:t>
             </a:r>
             <a:endParaRPr lang="en-US" sz="1250" dirty="0"/>
           </a:p>
@@ -4929,7 +4908,7 @@
                 <a:ea typeface="Calibri" pitchFamily="34" charset="-122"/>
                 <a:cs typeface="Calibri" pitchFamily="34" charset="-120"/>
               </a:rPr>
-              <a:t>yᵀw ≥ floor</a:t>
+              <a:t>y'w ≥ floor</a:t>
             </a:r>
             <a:endParaRPr lang="en-US" sz="1350" dirty="0"/>
           </a:p>
@@ -5068,7 +5047,7 @@
                 <a:ea typeface="Calibri" pitchFamily="34" charset="-122"/>
                 <a:cs typeface="Calibri" pitchFamily="34" charset="-120"/>
               </a:rPr>
-              <a:t>CVaRα scenario penalty</a:t>
+              <a:t>CVaR_α scenario penalty</a:t>
             </a:r>
             <a:endParaRPr lang="en-US" sz="1350" dirty="0"/>
           </a:p>

</xml_diff>

<commit_message>
Add Live Copilot demo slide (allocation screenshot) to deck
Embeds the running dashboard as a slide so the demo shows on-screen with no live-run risk. Deck now 12 slides.
</commit_message>
<xml_diff>
--- a/presentation/WISER_Vanguard_OMEGA.pptx
+++ b/presentation/WISER_Vanguard_OMEGA.pptx
@@ -16,9 +16,10 @@
     <p:sldId id="264" r:id="rId10"/>
     <p:sldId id="265" r:id="rId11"/>
     <p:sldId id="266" r:id="rId12"/>
+    <p:sldId id="267" r:id="rId13"/>
   </p:sldIdLst>
   <p:notesMasterIdLst>
-    <p:notesMasterId r:id="rId13"/>
+    <p:notesMasterId r:id="rId14"/>
   </p:notesMasterIdLst>
   <p:sldSz cx="12192000" cy="6858000"/>
   <p:notesSz cx="6858000" cy="12192000"/>
@@ -984,6 +985,94 @@
             <a:fld id="{F7021451-1387-4CA6-816F-3879F97B5CBC}" type="slidenum">
               <a:rPr lang="en-US"/>
               <a:t>11</a:t>
+            </a:fld>
+            <a:endParaRPr lang="en-US"/>
+          </a:p>
+        </p:txBody>
+      </p:sp>
+    </p:spTree>
+    <p:extLst>
+      <p:ext uri="{BB962C8B-B14F-4D97-AF65-F5344CB8AC3E}">
+        <p14:creationId xmlns:p14="http://schemas.microsoft.com/office/powerpoint/2010/main" val="1024086991"/>
+      </p:ext>
+    </p:extLst>
+  </p:cSld>
+  <p:clrMapOvr>
+    <a:masterClrMapping/>
+  </p:clrMapOvr>
+</p:notes>
+</file>
+
+<file path=ppt/notesSlides/notesSlide12.xml><?xml version="1.0" encoding="utf-8"?>
+<p:notes xmlns:a="http://schemas.openxmlformats.org/drawingml/2006/main" xmlns:r="http://schemas.openxmlformats.org/officeDocument/2006/relationships" xmlns:p="http://schemas.openxmlformats.org/presentationml/2006/main">
+  <p:cSld>
+    <p:spTree>
+      <p:nvGrpSpPr>
+        <p:cNvPr id="1" name=""/>
+        <p:cNvGrpSpPr/>
+        <p:nvPr/>
+      </p:nvGrpSpPr>
+      <p:grpSpPr>
+        <a:xfrm>
+          <a:off x="0" y="0"/>
+          <a:ext cx="0" cy="0"/>
+          <a:chOff x="0" y="0"/>
+          <a:chExt cx="0" cy="0"/>
+        </a:xfrm>
+      </p:grpSpPr>
+      <p:sp>
+        <p:nvSpPr>
+          <p:cNvPr id="2" name="Slide Image Placeholder 1"/>
+          <p:cNvSpPr>
+            <a:spLocks noGrp="1" noRot="1" noChangeAspect="1"/>
+          </p:cNvSpPr>
+          <p:nvPr>
+            <p:ph type="sldImg"/>
+          </p:nvPr>
+        </p:nvSpPr>
+        <p:spPr/>
+      </p:sp>
+      <p:sp>
+        <p:nvSpPr>
+          <p:cNvPr id="3" name="Notes Placeholder 2"/>
+          <p:cNvSpPr>
+            <a:spLocks noGrp="1"/>
+          </p:cNvSpPr>
+          <p:nvPr>
+            <p:ph type="body" idx="1"/>
+          </p:nvPr>
+        </p:nvSpPr>
+        <p:spPr/>
+        <p:txBody>
+          <a:bodyPr/>
+          <a:lstStyle/>
+          <a:p>
+            <a:r>
+              <a:rPr lang="en-US" dirty="0"/>
+              <a:t/>
+            </a:r>
+            <a:endParaRPr lang="en-US" dirty="0"/>
+          </a:p>
+        </p:txBody>
+      </p:sp>
+      <p:sp>
+        <p:nvSpPr>
+          <p:cNvPr id="4" name="Slide Number Placeholder 3"/>
+          <p:cNvSpPr>
+            <a:spLocks noGrp="1"/>
+          </p:cNvSpPr>
+          <p:nvPr>
+            <p:ph type="sldNum" sz="quarter" idx="10"/>
+          </p:nvPr>
+        </p:nvSpPr>
+        <p:spPr/>
+        <p:txBody>
+          <a:bodyPr/>
+          <a:lstStyle/>
+          <a:p>
+            <a:fld id="{F7021451-1387-4CA6-816F-3879F97B5CBC}" type="slidenum">
+              <a:rPr lang="en-US"/>
+              <a:t>12</a:t>
             </a:fld>
             <a:endParaRPr lang="en-US"/>
           </a:p>
@@ -2275,26 +2364,42 @@
                 <a:ea typeface="Cambria" pitchFamily="34" charset="-122"/>
                 <a:cs typeface="Cambria" pitchFamily="34" charset="-120"/>
               </a:rPr>
-              <a:t>Scope &amp; Roadmap</a:t>
+              <a:t>Hardware Audit: Real Transpiler, Real Heavy-Hex Lattice</a:t>
             </a:r>
             <a:endParaRPr lang="en-US" sz="3000" dirty="0"/>
           </a:p>
         </p:txBody>
       </p:sp>
-      <p:sp>
-        <p:nvSpPr>
-          <p:cNvPr id="3" name="Shape 1"/>
-          <p:cNvSpPr/>
-          <p:nvPr/>
-        </p:nvSpPr>
-        <p:spPr>
-          <a:xfrm>
-            <a:off x="502920" y="1371600"/>
-            <a:ext cx="5532120" cy="4480560"/>
+      <p:graphicFrame>
+        <p:nvGraphicFramePr>
+          <p:cNvPr id="3" name="Chart 0" descr=""/>
+          <p:cNvGraphicFramePr/>
+          <p:nvPr/>
+        </p:nvGraphicFramePr>
+        <p:xfrm>
+          <a:off x="502920" y="1325880"/>
+          <a:ext cx="6766560" cy="4480560"/>
+        </p:xfrm>
+        <a:graphic xmlns:a="http://schemas.openxmlformats.org/drawingml/2006/main">
+          <a:graphicData uri="http://schemas.openxmlformats.org/drawingml/2006/chart">
+            <c:chart xmlns:c="http://schemas.openxmlformats.org/drawingml/2006/chart" r:id="rId1"/>
+          </a:graphicData>
+        </a:graphic>
+      </p:graphicFrame>
+      <p:sp>
+        <p:nvSpPr>
+          <p:cNvPr id="4" name="Shape 1"/>
+          <p:cNvSpPr/>
+          <p:nvPr/>
+        </p:nvSpPr>
+        <p:spPr>
+          <a:xfrm>
+            <a:off x="7589520" y="1325880"/>
+            <a:ext cx="4069080" cy="4480560"/>
           </a:xfrm>
           <a:prstGeom prst="roundRect">
             <a:avLst>
-              <a:gd name="adj" fmla="val 1633"/>
+              <a:gd name="adj" fmla="val 1798"/>
             </a:avLst>
           </a:prstGeom>
           <a:solidFill>
@@ -2305,236 +2410,14 @@
       </p:sp>
       <p:sp>
         <p:nvSpPr>
-          <p:cNvPr id="4" name="Text 2"/>
-          <p:cNvSpPr/>
-          <p:nvPr/>
-        </p:nvSpPr>
-        <p:spPr>
-          <a:xfrm>
-            <a:off x="777240" y="1572768"/>
-            <a:ext cx="5029200" cy="4114800"/>
-          </a:xfrm>
-          <a:prstGeom prst="rect">
-            <a:avLst/>
-          </a:prstGeom>
-          <a:noFill/>
-          <a:ln/>
-        </p:spPr>
-        <p:txBody>
-          <a:bodyPr wrap="square" lIns="0" tIns="0" rIns="0" bIns="0" rtlCol="0" anchor="t"/>
-          <a:lstStyle/>
-          <a:p>
-            <a:pPr indent="0" marL="0">
-              <a:buNone/>
-            </a:pPr>
-            <a:r>
-              <a:rPr lang="en-US" sz="1600" b="1" dirty="0">
-                <a:solidFill>
-                  <a:srgbClr val="1E2761"/>
-                </a:solidFill>
-                <a:latin typeface="Calibri" pitchFamily="34" charset="0"/>
-                <a:ea typeface="Calibri" pitchFamily="34" charset="-122"/>
-                <a:cs typeface="Calibri" pitchFamily="34" charset="-120"/>
-              </a:rPr>
-              <a:t>Built for the hardware we're heading toward
-</a:t>
-            </a:r>
-            <a:endParaRPr lang="en-US" sz="1600" dirty="0"/>
-          </a:p>
-          <a:p>
-            <a:pPr marL="342900" indent="-342900">
-              <a:spcAft>
-                <a:spcPts val="1000"/>
-              </a:spcAft>
-              <a:buSzPct val="100000"/>
-              <a:buChar char="•"/>
-            </a:pPr>
-            <a:r>
-              <a:rPr lang="en-US" sz="1350" dirty="0">
-                <a:solidFill>
-                  <a:srgbClr val="1A1E2E"/>
-                </a:solidFill>
-                <a:latin typeface="Calibri" pitchFamily="34" charset="0"/>
-                <a:ea typeface="Calibri" pitchFamily="34" charset="-122"/>
-                <a:cs typeface="Calibri" pitchFamily="34" charset="-120"/>
-              </a:rPr>
-              <a:t>Every circuit ≤ 20 qubits — sized for the real NISQ devices of today, not a distant fault-tolerant future.</a:t>
-            </a:r>
-            <a:endParaRPr lang="en-US" sz="1600" dirty="0"/>
-          </a:p>
-          <a:p>
-            <a:pPr marL="342900" indent="-342900">
-              <a:spcAft>
-                <a:spcPts val="1000"/>
-              </a:spcAft>
-              <a:buSzPct val="100000"/>
-              <a:buChar char="•"/>
-            </a:pPr>
-            <a:r>
-              <a:rPr lang="en-US" sz="1350" dirty="0">
-                <a:solidFill>
-                  <a:srgbClr val="1A1E2E"/>
-                </a:solidFill>
-                <a:latin typeface="Calibri" pitchFamily="34" charset="0"/>
-                <a:ea typeface="Calibri" pitchFamily="34" charset="-122"/>
-                <a:cs typeface="Calibri" pitchFamily="34" charset="-120"/>
-              </a:rPr>
-              <a:t>Compliance gate and per-run audit trail packaged as a deployable engine — not just a notebook.</a:t>
-            </a:r>
-            <a:endParaRPr lang="en-US" sz="1600" dirty="0"/>
-          </a:p>
-          <a:p>
-            <a:pPr marL="342900" indent="-342900">
-              <a:buSzPct val="100000"/>
-              <a:buChar char="•"/>
-            </a:pPr>
-            <a:r>
-              <a:rPr lang="en-US" sz="1350" dirty="0">
-                <a:solidFill>
-                  <a:srgbClr val="1A1E2E"/>
-                </a:solidFill>
-                <a:latin typeface="Calibri" pitchFamily="34" charset="0"/>
-                <a:ea typeface="Calibri" pitchFamily="34" charset="-122"/>
-                <a:cs typeface="Calibri" pitchFamily="34" charset="-120"/>
-              </a:rPr>
-              <a:t>Directly relevant: every institutional fund must hold a fixed set of names under hard mandates.</a:t>
-            </a:r>
-            <a:endParaRPr lang="en-US" sz="1600" dirty="0"/>
-          </a:p>
-        </p:txBody>
-      </p:sp>
-      <p:sp>
-        <p:nvSpPr>
-          <p:cNvPr id="5" name="Shape 3"/>
-          <p:cNvSpPr/>
-          <p:nvPr/>
-        </p:nvSpPr>
-        <p:spPr>
-          <a:xfrm>
-            <a:off x="6519672" y="1371600"/>
-            <a:ext cx="5532120" cy="4480560"/>
-          </a:xfrm>
-          <a:prstGeom prst="roundRect">
-            <a:avLst>
-              <a:gd name="adj" fmla="val 1633"/>
-            </a:avLst>
-          </a:prstGeom>
-          <a:solidFill>
-            <a:srgbClr val="F0F4FB"/>
-          </a:solidFill>
-          <a:ln/>
-        </p:spPr>
-      </p:sp>
-      <p:sp>
-        <p:nvSpPr>
-          <p:cNvPr id="6" name="Text 4"/>
-          <p:cNvSpPr/>
-          <p:nvPr/>
-        </p:nvSpPr>
-        <p:spPr>
-          <a:xfrm>
-            <a:off x="6793992" y="1572768"/>
-            <a:ext cx="5029200" cy="4114800"/>
-          </a:xfrm>
-          <a:prstGeom prst="rect">
-            <a:avLst/>
-          </a:prstGeom>
-          <a:noFill/>
-          <a:ln/>
-        </p:spPr>
-        <p:txBody>
-          <a:bodyPr wrap="square" lIns="0" tIns="0" rIns="0" bIns="0" rtlCol="0" anchor="t"/>
-          <a:lstStyle/>
-          <a:p>
-            <a:pPr indent="0" marL="0">
-              <a:buNone/>
-            </a:pPr>
-            <a:r>
-              <a:rPr lang="en-US" sz="1600" b="1" dirty="0">
-                <a:solidFill>
-                  <a:srgbClr val="02C39A"/>
-                </a:solidFill>
-                <a:latin typeface="Calibri" pitchFamily="34" charset="0"/>
-                <a:ea typeface="Calibri" pitchFamily="34" charset="-122"/>
-                <a:cs typeface="Calibri" pitchFamily="34" charset="-120"/>
-              </a:rPr>
-              <a:t>The path to practice
-</a:t>
-            </a:r>
-            <a:endParaRPr lang="en-US" sz="1600" dirty="0"/>
-          </a:p>
-          <a:p>
-            <a:pPr marL="342900" indent="-342900">
-              <a:spcAft>
-                <a:spcPts val="1000"/>
-              </a:spcAft>
-              <a:buSzPct val="100000"/>
-              <a:buChar char="•"/>
-            </a:pPr>
-            <a:r>
-              <a:rPr lang="en-US" sz="1350" dirty="0">
-                <a:solidFill>
-                  <a:srgbClr val="1A1E2E"/>
-                </a:solidFill>
-                <a:latin typeface="Calibri" pitchFamily="34" charset="0"/>
-                <a:ea typeface="Calibri" pitchFamily="34" charset="-122"/>
-                <a:cs typeface="Calibri" pitchFamily="34" charset="-120"/>
-              </a:rPr>
-              <a:t>Execute on a real QPU — circuits are already compiled to the heavy-hex layout, SWAP-free.</a:t>
-            </a:r>
-            <a:endParaRPr lang="en-US" sz="1600" dirty="0"/>
-          </a:p>
-          <a:p>
-            <a:pPr marL="342900" indent="-342900">
-              <a:spcAft>
-                <a:spcPts val="1000"/>
-              </a:spcAft>
-              <a:buSzPct val="100000"/>
-              <a:buChar char="•"/>
-            </a:pPr>
-            <a:r>
-              <a:rPr lang="en-US" sz="1350" dirty="0">
-                <a:solidFill>
-                  <a:srgbClr val="1A1E2E"/>
-                </a:solidFill>
-                <a:latin typeface="Calibri" pitchFamily="34" charset="0"/>
-                <a:ea typeface="Calibri" pitchFamily="34" charset="-122"/>
-                <a:cs typeface="Calibri" pitchFamily="34" charset="-120"/>
-              </a:rPr>
-              <a:t>Scale to cluster sizes where classical enumeration becomes intractable — where quantum earns its keep.</a:t>
-            </a:r>
-            <a:endParaRPr lang="en-US" sz="1600" dirty="0"/>
-          </a:p>
-          <a:p>
-            <a:pPr marL="342900" indent="-342900">
-              <a:buSzPct val="100000"/>
-              <a:buChar char="•"/>
-            </a:pPr>
-            <a:r>
-              <a:rPr lang="en-US" sz="1350" dirty="0">
-                <a:solidFill>
-                  <a:srgbClr val="1A1E2E"/>
-                </a:solidFill>
-                <a:latin typeface="Calibri" pitchFamily="34" charset="0"/>
-                <a:ea typeface="Calibri" pitchFamily="34" charset="-122"/>
-                <a:cs typeface="Calibri" pitchFamily="34" charset="-120"/>
-              </a:rPr>
-              <a:t>Integrate a professional risk model and live data feeds for production deployment.</a:t>
-            </a:r>
-            <a:endParaRPr lang="en-US" sz="1600" dirty="0"/>
-          </a:p>
-        </p:txBody>
-      </p:sp>
-      <p:sp>
-        <p:nvSpPr>
-          <p:cNvPr id="7" name="Text 5"/>
-          <p:cNvSpPr/>
-          <p:nvPr/>
-        </p:nvSpPr>
-        <p:spPr>
-          <a:xfrm>
-            <a:off x="502920" y="5989320"/>
-            <a:ext cx="11155680" cy="548640"/>
+          <p:cNvPr id="5" name="Text 2"/>
+          <p:cNvSpPr/>
+          <p:nvPr/>
+        </p:nvSpPr>
+        <p:spPr>
+          <a:xfrm>
+            <a:off x="7772400" y="1645920"/>
+            <a:ext cx="3703320" cy="868680"/>
           </a:xfrm>
           <a:prstGeom prst="rect">
             <a:avLst/>
@@ -2546,11 +2429,50 @@
           <a:bodyPr wrap="square" lIns="0" tIns="0" rIns="0" bIns="0" rtlCol="0" anchor="ctr"/>
           <a:lstStyle/>
           <a:p>
-            <a:pPr indent="0" marL="0">
-              <a:buNone/>
-            </a:pPr>
-            <a:r>
-              <a:rPr lang="en-US" sz="1350" i="1" dirty="0">
+            <a:pPr algn="ctr" indent="0" marL="0">
+              <a:buNone/>
+            </a:pPr>
+            <a:r>
+              <a:rPr lang="en-US" sz="4000" b="1" dirty="0">
+                <a:solidFill>
+                  <a:srgbClr val="C0392B"/>
+                </a:solidFill>
+                <a:latin typeface="Calibri" pitchFamily="34" charset="0"/>
+                <a:ea typeface="Calibri" pitchFamily="34" charset="-122"/>
+                <a:cs typeface="Calibri" pitchFamily="34" charset="-120"/>
+              </a:rPr>
+              <a:t>14,630</a:t>
+            </a:r>
+            <a:endParaRPr lang="en-US" sz="4000" dirty="0"/>
+          </a:p>
+        </p:txBody>
+      </p:sp>
+      <p:sp>
+        <p:nvSpPr>
+          <p:cNvPr id="6" name="Text 3"/>
+          <p:cNvSpPr/>
+          <p:nvPr/>
+        </p:nvSpPr>
+        <p:spPr>
+          <a:xfrm>
+            <a:off x="7772400" y="2487168"/>
+            <a:ext cx="3703320" cy="685800"/>
+          </a:xfrm>
+          <a:prstGeom prst="rect">
+            <a:avLst/>
+          </a:prstGeom>
+          <a:noFill/>
+          <a:ln/>
+        </p:spPr>
+        <p:txBody>
+          <a:bodyPr wrap="square" lIns="0" tIns="0" rIns="0" bIns="0" rtlCol="0" anchor="ctr"/>
+          <a:lstStyle/>
+          <a:p>
+            <a:pPr algn="ctr" indent="0" marL="0">
+              <a:buNone/>
+            </a:pPr>
+            <a:r>
+              <a:rPr lang="en-US" sz="1250" dirty="0">
                 <a:solidFill>
                   <a:srgbClr val="5A6478"/>
                 </a:solidFill>
@@ -2558,9 +2480,126 @@
                 <a:ea typeface="Calibri" pitchFamily="34" charset="-122"/>
                 <a:cs typeface="Calibri" pitchFamily="34" charset="-120"/>
               </a:rPr>
-              <a:t>At today's scale the advantage is structural — a hard compliance guarantee and a hardware-ready architecture, built to earn quantum advantage as problem sizes grow.</a:t>
-            </a:r>
-            <a:endParaRPr lang="en-US" sz="1350" dirty="0"/>
+              <a:t>SWAP-tax CX gates the monolithic penalty circuit pays for routing alone</a:t>
+            </a:r>
+            <a:endParaRPr lang="en-US" sz="1250" dirty="0"/>
+          </a:p>
+        </p:txBody>
+      </p:sp>
+      <p:sp>
+        <p:nvSpPr>
+          <p:cNvPr id="7" name="Text 4"/>
+          <p:cNvSpPr/>
+          <p:nvPr/>
+        </p:nvSpPr>
+        <p:spPr>
+          <a:xfrm>
+            <a:off x="7772400" y="3200400"/>
+            <a:ext cx="3703320" cy="868680"/>
+          </a:xfrm>
+          <a:prstGeom prst="rect">
+            <a:avLst/>
+          </a:prstGeom>
+          <a:noFill/>
+          <a:ln/>
+        </p:spPr>
+        <p:txBody>
+          <a:bodyPr wrap="square" lIns="0" tIns="0" rIns="0" bIns="0" rtlCol="0" anchor="ctr"/>
+          <a:lstStyle/>
+          <a:p>
+            <a:pPr algn="ctr" indent="0" marL="0">
+              <a:buNone/>
+            </a:pPr>
+            <a:r>
+              <a:rPr lang="en-US" sz="4000" b="1" dirty="0">
+                <a:solidFill>
+                  <a:srgbClr val="C0392B"/>
+                </a:solidFill>
+                <a:latin typeface="Calibri" pitchFamily="34" charset="0"/>
+                <a:ea typeface="Calibri" pitchFamily="34" charset="-122"/>
+                <a:cs typeface="Calibri" pitchFamily="34" charset="-120"/>
+              </a:rPr>
+              <a:t>14×</a:t>
+            </a:r>
+            <a:endParaRPr lang="en-US" sz="4000" dirty="0"/>
+          </a:p>
+        </p:txBody>
+      </p:sp>
+      <p:sp>
+        <p:nvSpPr>
+          <p:cNvPr id="8" name="Text 5"/>
+          <p:cNvSpPr/>
+          <p:nvPr/>
+        </p:nvSpPr>
+        <p:spPr>
+          <a:xfrm>
+            <a:off x="7772400" y="4041648"/>
+            <a:ext cx="3703320" cy="685800"/>
+          </a:xfrm>
+          <a:prstGeom prst="rect">
+            <a:avLst/>
+          </a:prstGeom>
+          <a:noFill/>
+          <a:ln/>
+        </p:spPr>
+        <p:txBody>
+          <a:bodyPr wrap="square" lIns="0" tIns="0" rIns="0" bIns="0" rtlCol="0" anchor="ctr"/>
+          <a:lstStyle/>
+          <a:p>
+            <a:pPr algn="ctr" indent="0" marL="0">
+              <a:buNone/>
+            </a:pPr>
+            <a:r>
+              <a:rPr lang="en-US" sz="1250" dirty="0">
+                <a:solidFill>
+                  <a:srgbClr val="5A6478"/>
+                </a:solidFill>
+                <a:latin typeface="Calibri" pitchFamily="34" charset="0"/>
+                <a:ea typeface="Calibri" pitchFamily="34" charset="-122"/>
+                <a:cs typeface="Calibri" pitchFamily="34" charset="-120"/>
+              </a:rPr>
+              <a:t>more noise exposure than OMEGA's largest circuit — same N=100 problem</a:t>
+            </a:r>
+            <a:endParaRPr lang="en-US" sz="1250" dirty="0"/>
+          </a:p>
+        </p:txBody>
+      </p:sp>
+      <p:sp>
+        <p:nvSpPr>
+          <p:cNvPr id="9" name="Text 6"/>
+          <p:cNvSpPr/>
+          <p:nvPr/>
+        </p:nvSpPr>
+        <p:spPr>
+          <a:xfrm>
+            <a:off x="502920" y="5897880"/>
+            <a:ext cx="11155680" cy="594360"/>
+          </a:xfrm>
+          <a:prstGeom prst="rect">
+            <a:avLst/>
+          </a:prstGeom>
+          <a:noFill/>
+          <a:ln/>
+        </p:spPr>
+        <p:txBody>
+          <a:bodyPr wrap="square" lIns="0" tIns="0" rIns="0" bIns="0" rtlCol="0" anchor="ctr"/>
+          <a:lstStyle/>
+          <a:p>
+            <a:pPr indent="0" marL="0">
+              <a:buNone/>
+            </a:pPr>
+            <a:r>
+              <a:rPr lang="en-US" sz="1300" i="1" dirty="0">
+                <a:solidFill>
+                  <a:srgbClr val="5A6478"/>
+                </a:solidFill>
+                <a:latin typeface="Calibri" pitchFamily="34" charset="0"/>
+                <a:ea typeface="Calibri" pitchFamily="34" charset="-122"/>
+                <a:cs typeface="Calibri" pitchFamily="34" charset="-120"/>
+              </a:rPr>
+              <a:t>At matched size their circuit is cheaper (530 vs 1,735) — we show it. The point is architectural: they can never run small; we never need to run big.</a:t>
+            </a:r>
+            <a:endParaRPr lang="en-US" sz="1300" dirty="0"/>
           </a:p>
         </p:txBody>
       </p:sp>
@@ -2575,6 +2614,360 @@
 <file path=ppt/slides/slide11.xml><?xml version="1.0" encoding="utf-8"?>
 <p:sld xmlns:a="http://schemas.openxmlformats.org/drawingml/2006/main" xmlns:r="http://schemas.openxmlformats.org/officeDocument/2006/relationships" xmlns:p="http://schemas.openxmlformats.org/presentationml/2006/main">
   <p:cSld name="Slide 11">
+    <p:bg>
+      <p:bgPr>
+        <a:solidFill>
+          <a:srgbClr val="FFFFFF"/>
+        </a:solidFill>
+      </p:bgPr>
+    </p:bg>
+    <p:spTree>
+      <p:nvGrpSpPr>
+        <p:cNvPr id="1" name=""/>
+        <p:cNvGrpSpPr/>
+        <p:nvPr/>
+      </p:nvGrpSpPr>
+      <p:grpSpPr>
+        <a:xfrm>
+          <a:off x="0" y="0"/>
+          <a:ext cx="0" cy="0"/>
+          <a:chOff x="0" y="0"/>
+          <a:chExt cx="0" cy="0"/>
+        </a:xfrm>
+      </p:grpSpPr>
+      <p:sp>
+        <p:nvSpPr>
+          <p:cNvPr id="2" name="Text 0"/>
+          <p:cNvSpPr/>
+          <p:nvPr/>
+        </p:nvSpPr>
+        <p:spPr>
+          <a:xfrm>
+            <a:off x="502920" y="320040"/>
+            <a:ext cx="11183112" cy="777240"/>
+          </a:xfrm>
+          <a:prstGeom prst="rect">
+            <a:avLst/>
+          </a:prstGeom>
+          <a:noFill/>
+          <a:ln/>
+        </p:spPr>
+        <p:txBody>
+          <a:bodyPr wrap="square" lIns="0" tIns="0" rIns="0" bIns="0" rtlCol="0" anchor="ctr"/>
+          <a:lstStyle/>
+          <a:p>
+            <a:pPr indent="0" marL="0">
+              <a:buNone/>
+            </a:pPr>
+            <a:r>
+              <a:rPr lang="en-US" sz="3000" b="1" dirty="0">
+                <a:solidFill>
+                  <a:srgbClr val="1A1E2E"/>
+                </a:solidFill>
+                <a:latin typeface="Cambria" pitchFamily="34" charset="0"/>
+                <a:ea typeface="Cambria" pitchFamily="34" charset="-122"/>
+                <a:cs typeface="Cambria" pitchFamily="34" charset="-120"/>
+              </a:rPr>
+              <a:t>Scope &amp; Roadmap</a:t>
+            </a:r>
+            <a:endParaRPr lang="en-US" sz="3000" dirty="0"/>
+          </a:p>
+        </p:txBody>
+      </p:sp>
+      <p:sp>
+        <p:nvSpPr>
+          <p:cNvPr id="3" name="Shape 1"/>
+          <p:cNvSpPr/>
+          <p:nvPr/>
+        </p:nvSpPr>
+        <p:spPr>
+          <a:xfrm>
+            <a:off x="502920" y="1371600"/>
+            <a:ext cx="5532120" cy="4480560"/>
+          </a:xfrm>
+          <a:prstGeom prst="roundRect">
+            <a:avLst>
+              <a:gd name="adj" fmla="val 1633"/>
+            </a:avLst>
+          </a:prstGeom>
+          <a:solidFill>
+            <a:srgbClr val="F0F4FB"/>
+          </a:solidFill>
+          <a:ln/>
+        </p:spPr>
+      </p:sp>
+      <p:sp>
+        <p:nvSpPr>
+          <p:cNvPr id="4" name="Text 2"/>
+          <p:cNvSpPr/>
+          <p:nvPr/>
+        </p:nvSpPr>
+        <p:spPr>
+          <a:xfrm>
+            <a:off x="777240" y="1572768"/>
+            <a:ext cx="5029200" cy="4114800"/>
+          </a:xfrm>
+          <a:prstGeom prst="rect">
+            <a:avLst/>
+          </a:prstGeom>
+          <a:noFill/>
+          <a:ln/>
+        </p:spPr>
+        <p:txBody>
+          <a:bodyPr wrap="square" lIns="0" tIns="0" rIns="0" bIns="0" rtlCol="0" anchor="t"/>
+          <a:lstStyle/>
+          <a:p>
+            <a:pPr indent="0" marL="0">
+              <a:buNone/>
+            </a:pPr>
+            <a:r>
+              <a:rPr lang="en-US" sz="1600" b="1" dirty="0">
+                <a:solidFill>
+                  <a:srgbClr val="1E2761"/>
+                </a:solidFill>
+                <a:latin typeface="Calibri" pitchFamily="34" charset="0"/>
+                <a:ea typeface="Calibri" pitchFamily="34" charset="-122"/>
+                <a:cs typeface="Calibri" pitchFamily="34" charset="-120"/>
+              </a:rPr>
+              <a:t>Built for the hardware we're heading toward
+</a:t>
+            </a:r>
+            <a:endParaRPr lang="en-US" sz="1600" dirty="0"/>
+          </a:p>
+          <a:p>
+            <a:pPr marL="342900" indent="-342900">
+              <a:spcAft>
+                <a:spcPts val="1000"/>
+              </a:spcAft>
+              <a:buSzPct val="100000"/>
+              <a:buChar char="•"/>
+            </a:pPr>
+            <a:r>
+              <a:rPr lang="en-US" sz="1350" dirty="0">
+                <a:solidFill>
+                  <a:srgbClr val="1A1E2E"/>
+                </a:solidFill>
+                <a:latin typeface="Calibri" pitchFamily="34" charset="0"/>
+                <a:ea typeface="Calibri" pitchFamily="34" charset="-122"/>
+                <a:cs typeface="Calibri" pitchFamily="34" charset="-120"/>
+              </a:rPr>
+              <a:t>Every circuit ≤ 20 qubits — sized for the real NISQ devices of today, not a distant fault-tolerant future.</a:t>
+            </a:r>
+            <a:endParaRPr lang="en-US" sz="1600" dirty="0"/>
+          </a:p>
+          <a:p>
+            <a:pPr marL="342900" indent="-342900">
+              <a:spcAft>
+                <a:spcPts val="1000"/>
+              </a:spcAft>
+              <a:buSzPct val="100000"/>
+              <a:buChar char="•"/>
+            </a:pPr>
+            <a:r>
+              <a:rPr lang="en-US" sz="1350" dirty="0">
+                <a:solidFill>
+                  <a:srgbClr val="1A1E2E"/>
+                </a:solidFill>
+                <a:latin typeface="Calibri" pitchFamily="34" charset="0"/>
+                <a:ea typeface="Calibri" pitchFamily="34" charset="-122"/>
+                <a:cs typeface="Calibri" pitchFamily="34" charset="-120"/>
+              </a:rPr>
+              <a:t>Compliance gate and per-run audit trail packaged as a deployable engine — not just a notebook.</a:t>
+            </a:r>
+            <a:endParaRPr lang="en-US" sz="1600" dirty="0"/>
+          </a:p>
+          <a:p>
+            <a:pPr marL="342900" indent="-342900">
+              <a:buSzPct val="100000"/>
+              <a:buChar char="•"/>
+            </a:pPr>
+            <a:r>
+              <a:rPr lang="en-US" sz="1350" dirty="0">
+                <a:solidFill>
+                  <a:srgbClr val="1A1E2E"/>
+                </a:solidFill>
+                <a:latin typeface="Calibri" pitchFamily="34" charset="0"/>
+                <a:ea typeface="Calibri" pitchFamily="34" charset="-122"/>
+                <a:cs typeface="Calibri" pitchFamily="34" charset="-120"/>
+              </a:rPr>
+              <a:t>Directly relevant: every institutional fund must hold a fixed set of names under hard mandates.</a:t>
+            </a:r>
+            <a:endParaRPr lang="en-US" sz="1600" dirty="0"/>
+          </a:p>
+        </p:txBody>
+      </p:sp>
+      <p:sp>
+        <p:nvSpPr>
+          <p:cNvPr id="5" name="Shape 3"/>
+          <p:cNvSpPr/>
+          <p:nvPr/>
+        </p:nvSpPr>
+        <p:spPr>
+          <a:xfrm>
+            <a:off x="6519672" y="1371600"/>
+            <a:ext cx="5532120" cy="4480560"/>
+          </a:xfrm>
+          <a:prstGeom prst="roundRect">
+            <a:avLst>
+              <a:gd name="adj" fmla="val 1633"/>
+            </a:avLst>
+          </a:prstGeom>
+          <a:solidFill>
+            <a:srgbClr val="F0F4FB"/>
+          </a:solidFill>
+          <a:ln/>
+        </p:spPr>
+      </p:sp>
+      <p:sp>
+        <p:nvSpPr>
+          <p:cNvPr id="6" name="Text 4"/>
+          <p:cNvSpPr/>
+          <p:nvPr/>
+        </p:nvSpPr>
+        <p:spPr>
+          <a:xfrm>
+            <a:off x="6793992" y="1572768"/>
+            <a:ext cx="5029200" cy="4114800"/>
+          </a:xfrm>
+          <a:prstGeom prst="rect">
+            <a:avLst/>
+          </a:prstGeom>
+          <a:noFill/>
+          <a:ln/>
+        </p:spPr>
+        <p:txBody>
+          <a:bodyPr wrap="square" lIns="0" tIns="0" rIns="0" bIns="0" rtlCol="0" anchor="t"/>
+          <a:lstStyle/>
+          <a:p>
+            <a:pPr indent="0" marL="0">
+              <a:buNone/>
+            </a:pPr>
+            <a:r>
+              <a:rPr lang="en-US" sz="1600" b="1" dirty="0">
+                <a:solidFill>
+                  <a:srgbClr val="02C39A"/>
+                </a:solidFill>
+                <a:latin typeface="Calibri" pitchFamily="34" charset="0"/>
+                <a:ea typeface="Calibri" pitchFamily="34" charset="-122"/>
+                <a:cs typeface="Calibri" pitchFamily="34" charset="-120"/>
+              </a:rPr>
+              <a:t>The path to practice
+</a:t>
+            </a:r>
+            <a:endParaRPr lang="en-US" sz="1600" dirty="0"/>
+          </a:p>
+          <a:p>
+            <a:pPr marL="342900" indent="-342900">
+              <a:spcAft>
+                <a:spcPts val="1000"/>
+              </a:spcAft>
+              <a:buSzPct val="100000"/>
+              <a:buChar char="•"/>
+            </a:pPr>
+            <a:r>
+              <a:rPr lang="en-US" sz="1350" dirty="0">
+                <a:solidFill>
+                  <a:srgbClr val="1A1E2E"/>
+                </a:solidFill>
+                <a:latin typeface="Calibri" pitchFamily="34" charset="0"/>
+                <a:ea typeface="Calibri" pitchFamily="34" charset="-122"/>
+                <a:cs typeface="Calibri" pitchFamily="34" charset="-120"/>
+              </a:rPr>
+              <a:t>Execute on a real QPU — circuits are already compiled to the heavy-hex layout, SWAP-free.</a:t>
+            </a:r>
+            <a:endParaRPr lang="en-US" sz="1600" dirty="0"/>
+          </a:p>
+          <a:p>
+            <a:pPr marL="342900" indent="-342900">
+              <a:spcAft>
+                <a:spcPts val="1000"/>
+              </a:spcAft>
+              <a:buSzPct val="100000"/>
+              <a:buChar char="•"/>
+            </a:pPr>
+            <a:r>
+              <a:rPr lang="en-US" sz="1350" dirty="0">
+                <a:solidFill>
+                  <a:srgbClr val="1A1E2E"/>
+                </a:solidFill>
+                <a:latin typeface="Calibri" pitchFamily="34" charset="0"/>
+                <a:ea typeface="Calibri" pitchFamily="34" charset="-122"/>
+                <a:cs typeface="Calibri" pitchFamily="34" charset="-120"/>
+              </a:rPr>
+              <a:t>Scale to cluster sizes where classical enumeration becomes intractable — where quantum earns its keep.</a:t>
+            </a:r>
+            <a:endParaRPr lang="en-US" sz="1600" dirty="0"/>
+          </a:p>
+          <a:p>
+            <a:pPr marL="342900" indent="-342900">
+              <a:buSzPct val="100000"/>
+              <a:buChar char="•"/>
+            </a:pPr>
+            <a:r>
+              <a:rPr lang="en-US" sz="1350" dirty="0">
+                <a:solidFill>
+                  <a:srgbClr val="1A1E2E"/>
+                </a:solidFill>
+                <a:latin typeface="Calibri" pitchFamily="34" charset="0"/>
+                <a:ea typeface="Calibri" pitchFamily="34" charset="-122"/>
+                <a:cs typeface="Calibri" pitchFamily="34" charset="-120"/>
+              </a:rPr>
+              <a:t>Integrate a professional risk model and live data feeds for production deployment.</a:t>
+            </a:r>
+            <a:endParaRPr lang="en-US" sz="1600" dirty="0"/>
+          </a:p>
+        </p:txBody>
+      </p:sp>
+      <p:sp>
+        <p:nvSpPr>
+          <p:cNvPr id="7" name="Text 5"/>
+          <p:cNvSpPr/>
+          <p:nvPr/>
+        </p:nvSpPr>
+        <p:spPr>
+          <a:xfrm>
+            <a:off x="502920" y="5989320"/>
+            <a:ext cx="11155680" cy="548640"/>
+          </a:xfrm>
+          <a:prstGeom prst="rect">
+            <a:avLst/>
+          </a:prstGeom>
+          <a:noFill/>
+          <a:ln/>
+        </p:spPr>
+        <p:txBody>
+          <a:bodyPr wrap="square" lIns="0" tIns="0" rIns="0" bIns="0" rtlCol="0" anchor="ctr"/>
+          <a:lstStyle/>
+          <a:p>
+            <a:pPr indent="0" marL="0">
+              <a:buNone/>
+            </a:pPr>
+            <a:r>
+              <a:rPr lang="en-US" sz="1350" i="1" dirty="0">
+                <a:solidFill>
+                  <a:srgbClr val="5A6478"/>
+                </a:solidFill>
+                <a:latin typeface="Calibri" pitchFamily="34" charset="0"/>
+                <a:ea typeface="Calibri" pitchFamily="34" charset="-122"/>
+                <a:cs typeface="Calibri" pitchFamily="34" charset="-120"/>
+              </a:rPr>
+              <a:t>At today's scale the advantage is structural — a hard compliance guarantee and a hardware-ready architecture, built to earn quantum advantage as problem sizes grow.</a:t>
+            </a:r>
+            <a:endParaRPr lang="en-US" sz="1350" dirty="0"/>
+          </a:p>
+        </p:txBody>
+      </p:sp>
+    </p:spTree>
+  </p:cSld>
+  <p:clrMapOvr>
+    <a:masterClrMapping/>
+  </p:clrMapOvr>
+</p:sld>
+</file>
+
+<file path=ppt/slides/slide12.xml><?xml version="1.0" encoding="utf-8"?>
+<p:sld xmlns:a="http://schemas.openxmlformats.org/drawingml/2006/main" xmlns:r="http://schemas.openxmlformats.org/officeDocument/2006/relationships" xmlns:p="http://schemas.openxmlformats.org/presentationml/2006/main">
+  <p:cSld name="Slide 12">
     <p:bg>
       <p:bgPr>
         <a:solidFill>
@@ -5911,65 +6304,57 @@
                 <a:ea typeface="Cambria" pitchFamily="34" charset="-122"/>
                 <a:cs typeface="Cambria" pitchFamily="34" charset="-120"/>
               </a:rPr>
-              <a:t>Adversarial Benchmark: We Ran Their Stack, Correctly</a:t>
+              <a:t>The Allocation Copilot — Live on Real Market Data</a:t>
             </a:r>
             <a:endParaRPr lang="en-US" sz="3000" dirty="0"/>
           </a:p>
         </p:txBody>
       </p:sp>
-      <p:sp>
-        <p:nvSpPr>
-          <p:cNvPr id="3" name="Text 1"/>
-          <p:cNvSpPr/>
-          <p:nvPr/>
-        </p:nvSpPr>
-        <p:spPr>
-          <a:xfrm>
-            <a:off x="502920" y="1188720"/>
-            <a:ext cx="11155680" cy="548640"/>
-          </a:xfrm>
-          <a:prstGeom prst="rect">
-            <a:avLst/>
-          </a:prstGeom>
-          <a:noFill/>
-          <a:ln/>
-        </p:spPr>
-        <p:txBody>
-          <a:bodyPr wrap="square" lIns="0" tIns="0" rIns="0" bIns="0" rtlCol="0" anchor="ctr"/>
-          <a:lstStyle/>
-          <a:p>
-            <a:pPr indent="0" marL="0">
-              <a:buNone/>
-            </a:pPr>
-            <a:r>
-              <a:rPr lang="en-US" sz="1400" dirty="0">
-                <a:solidFill>
-                  <a:srgbClr val="5A6478"/>
-                </a:solidFill>
-                <a:latin typeface="Calibri" pitchFamily="34" charset="0"/>
-                <a:ea typeface="Calibri" pitchFamily="34" charset="-122"/>
-                <a:cs typeface="Calibri" pitchFamily="34" charset="-120"/>
-              </a:rPr>
-              <a:t>Full-strength replication of the DBSCAN + soft-penalty-QUBO + X-mixer pipeline — encoding verified exact against brute force. Failure modes are measured, never scripted.</a:t>
-            </a:r>
-            <a:endParaRPr lang="en-US" sz="1400" dirty="0"/>
-          </a:p>
-        </p:txBody>
-      </p:sp>
-      <p:sp>
-        <p:nvSpPr>
-          <p:cNvPr id="4" name="Shape 2"/>
-          <p:cNvSpPr/>
-          <p:nvPr/>
-        </p:nvSpPr>
-        <p:spPr>
-          <a:xfrm>
-            <a:off x="502920" y="1965960"/>
-            <a:ext cx="3657600" cy="2651760"/>
+      <p:pic>
+        <p:nvPicPr>
+          <p:cNvPr id="3" name="Image 0" descr="C:\Users\hasti\Desktop\WISER\docs\screenshots\01-allocation.png">    </p:cNvPr>
+          <p:cNvPicPr>
+            <a:picLocks noChangeAspect="1"/>
+          </p:cNvPicPr>
+          <p:nvPr/>
+        </p:nvPicPr>
+        <p:blipFill>
+          <a:blip r:embed="rId1"/>
+          <a:stretch>
+            <a:fillRect/>
+          </a:stretch>
+        </p:blipFill>
+        <p:spPr>
+          <a:xfrm>
+            <a:off x="457200" y="1234440"/>
+            <a:ext cx="7461504" cy="4480560"/>
+          </a:xfrm>
+          <a:prstGeom prst="rect">
+            <a:avLst/>
+          </a:prstGeom>
+          <a:effectLst>
+            <a:outerShdw sx="100000" sy="100000" kx="0" ky="0" algn="bl" rotWithShape="0" blurRad="76200" dist="25400" dir="5400000">
+              <a:srgbClr val="9AA6B8">
+                <a:alpha val="45000"/>
+              </a:srgbClr>
+            </a:outerShdw>
+          </a:effectLst>
+        </p:spPr>
+      </p:pic>
+      <p:sp>
+        <p:nvSpPr>
+          <p:cNvPr id="4" name="Shape 1"/>
+          <p:cNvSpPr/>
+          <p:nvPr/>
+        </p:nvSpPr>
+        <p:spPr>
+          <a:xfrm>
+            <a:off x="8183880" y="1234440"/>
+            <a:ext cx="3547872" cy="4480560"/>
           </a:xfrm>
           <a:prstGeom prst="roundRect">
             <a:avLst>
-              <a:gd name="adj" fmla="val 2759"/>
+              <a:gd name="adj" fmla="val 2062"/>
             </a:avLst>
           </a:prstGeom>
           <a:solidFill>
@@ -5980,14 +6365,138 @@
       </p:sp>
       <p:sp>
         <p:nvSpPr>
-          <p:cNvPr id="5" name="Text 3"/>
-          <p:cNvSpPr/>
-          <p:nvPr/>
-        </p:nvSpPr>
-        <p:spPr>
-          <a:xfrm>
-            <a:off x="704088" y="2176272"/>
-            <a:ext cx="3246120" cy="502920"/>
+          <p:cNvPr id="5" name="Text 2"/>
+          <p:cNvSpPr/>
+          <p:nvPr/>
+        </p:nvSpPr>
+        <p:spPr>
+          <a:xfrm>
+            <a:off x="8412480" y="1481328"/>
+            <a:ext cx="3108960" cy="4023360"/>
+          </a:xfrm>
+          <a:prstGeom prst="rect">
+            <a:avLst/>
+          </a:prstGeom>
+          <a:noFill/>
+          <a:ln/>
+        </p:spPr>
+        <p:txBody>
+          <a:bodyPr wrap="square" lIns="0" tIns="0" rIns="0" bIns="0" rtlCol="0" anchor="t"/>
+          <a:lstStyle/>
+          <a:p>
+            <a:pPr indent="0" marL="0">
+              <a:spcAft>
+                <a:spcPts val="1200"/>
+              </a:spcAft>
+              <a:buNone/>
+            </a:pPr>
+            <a:r>
+              <a:rPr lang="en-US" sz="1500" b="1" dirty="0">
+                <a:solidFill>
+                  <a:srgbClr val="1E2761"/>
+                </a:solidFill>
+                <a:latin typeface="Calibri" pitchFamily="34" charset="0"/>
+                <a:ea typeface="Calibri" pitchFamily="34" charset="-122"/>
+                <a:cs typeface="Calibri" pitchFamily="34" charset="-120"/>
+              </a:rPr>
+              <a:t>What you're seeing
+</a:t>
+            </a:r>
+            <a:endParaRPr lang="en-US" sz="1500" dirty="0"/>
+          </a:p>
+          <a:p>
+            <a:pPr marL="342900" indent="-342900">
+              <a:spcAft>
+                <a:spcPts val="1100"/>
+              </a:spcAft>
+              <a:buSzPct val="100000"/>
+              <a:buChar char="•"/>
+            </a:pPr>
+            <a:r>
+              <a:rPr lang="en-US" sz="1250" dirty="0">
+                <a:solidFill>
+                  <a:srgbClr val="1A1E2E"/>
+                </a:solidFill>
+                <a:latin typeface="Calibri" pitchFamily="34" charset="0"/>
+                <a:ea typeface="Calibri" pitchFamily="34" charset="-122"/>
+                <a:cs typeface="Calibri" pitchFamily="34" charset="-120"/>
+              </a:rPr>
+              <a:t>41 real ETFs, loaded offline — the same pipeline, unchanged.</a:t>
+            </a:r>
+            <a:endParaRPr lang="en-US" sz="1500" dirty="0"/>
+          </a:p>
+          <a:p>
+            <a:pPr marL="342900" indent="-342900">
+              <a:spcAft>
+                <a:spcPts val="1100"/>
+              </a:spcAft>
+              <a:buSzPct val="100000"/>
+              <a:buChar char="•"/>
+            </a:pPr>
+            <a:r>
+              <a:rPr lang="en-US" sz="1250" dirty="0">
+                <a:solidFill>
+                  <a:srgbClr val="1A1E2E"/>
+                </a:solidFill>
+                <a:latin typeface="Calibri" pitchFamily="34" charset="0"/>
+                <a:ea typeface="Calibri" pitchFamily="34" charset="-122"/>
+                <a:cs typeface="Calibri" pitchFamily="34" charset="-120"/>
+              </a:rPr>
+              <a:t>Zero hard-guardrail breaches — top metric, guaranteed by design.</a:t>
+            </a:r>
+            <a:endParaRPr lang="en-US" sz="1500" dirty="0"/>
+          </a:p>
+          <a:p>
+            <a:pPr marL="342900" indent="-342900">
+              <a:spcAft>
+                <a:spcPts val="1100"/>
+              </a:spcAft>
+              <a:buSzPct val="100000"/>
+              <a:buChar char="•"/>
+            </a:pPr>
+            <a:r>
+              <a:rPr lang="en-US" sz="1250" dirty="0">
+                <a:solidFill>
+                  <a:srgbClr val="1A1E2E"/>
+                </a:solidFill>
+                <a:latin typeface="Calibri" pitchFamily="34" charset="0"/>
+                <a:ea typeface="Calibri" pitchFamily="34" charset="-122"/>
+                <a:cs typeface="Calibri" pitchFamily="34" charset="-120"/>
+              </a:rPr>
+              <a:t>Weights pinned at the 10% cap and 1% floor — the constraints are visibly binding.</a:t>
+            </a:r>
+            <a:endParaRPr lang="en-US" sz="1500" dirty="0"/>
+          </a:p>
+          <a:p>
+            <a:pPr marL="342900" indent="-342900">
+              <a:buSzPct val="100000"/>
+              <a:buChar char="•"/>
+            </a:pPr>
+            <a:r>
+              <a:rPr lang="en-US" sz="1250" dirty="0">
+                <a:solidFill>
+                  <a:srgbClr val="1A1E2E"/>
+                </a:solidFill>
+                <a:latin typeface="Calibri" pitchFamily="34" charset="0"/>
+                <a:ea typeface="Calibri" pitchFamily="34" charset="-122"/>
+                <a:cs typeface="Calibri" pitchFamily="34" charset="-120"/>
+              </a:rPr>
+              <a:t>Four investor-goal sliders live in the sidebar.</a:t>
+            </a:r>
+            <a:endParaRPr lang="en-US" sz="1500" dirty="0"/>
+          </a:p>
+        </p:txBody>
+      </p:sp>
+      <p:sp>
+        <p:nvSpPr>
+          <p:cNvPr id="6" name="Text 3"/>
+          <p:cNvSpPr/>
+          <p:nvPr/>
+        </p:nvSpPr>
+        <p:spPr>
+          <a:xfrm>
+            <a:off x="457200" y="5943600"/>
+            <a:ext cx="11247120" cy="457200"/>
           </a:xfrm>
           <a:prstGeom prst="rect">
             <a:avLst/>
@@ -6003,331 +6512,17 @@
               <a:buNone/>
             </a:pPr>
             <a:r>
-              <a:rPr lang="en-US" sz="1500" b="1" dirty="0">
-                <a:solidFill>
-                  <a:srgbClr val="C0392B"/>
-                </a:solidFill>
-                <a:latin typeface="Calibri" pitchFamily="34" charset="0"/>
-                <a:ea typeface="Calibri" pitchFamily="34" charset="-122"/>
-                <a:cs typeface="Calibri" pitchFamily="34" charset="-120"/>
-              </a:rPr>
-              <a:t>λ = 0.05 (small penalty)</a:t>
-            </a:r>
-            <a:endParaRPr lang="en-US" sz="1500" dirty="0"/>
-          </a:p>
-        </p:txBody>
-      </p:sp>
-      <p:sp>
-        <p:nvSpPr>
-          <p:cNvPr id="6" name="Text 4"/>
-          <p:cNvSpPr/>
-          <p:nvPr/>
-        </p:nvSpPr>
-        <p:spPr>
-          <a:xfrm>
-            <a:off x="704088" y="2724912"/>
-            <a:ext cx="3246120" cy="1737360"/>
-          </a:xfrm>
-          <a:prstGeom prst="rect">
-            <a:avLst/>
-          </a:prstGeom>
-          <a:noFill/>
-          <a:ln/>
-        </p:spPr>
-        <p:txBody>
-          <a:bodyPr wrap="square" lIns="0" tIns="0" rIns="0" bIns="0" rtlCol="0" anchor="t"/>
-          <a:lstStyle/>
-          <a:p>
-            <a:pPr indent="0" marL="0">
-              <a:buNone/>
-            </a:pPr>
-            <a:r>
-              <a:rPr lang="en-US" sz="1350" dirty="0">
-                <a:solidFill>
-                  <a:srgbClr val="1A1E2E"/>
-                </a:solidFill>
-                <a:latin typeface="Calibri" pitchFamily="34" charset="0"/>
-                <a:ea typeface="Calibri" pitchFamily="34" charset="-122"/>
-                <a:cs typeface="Calibri" pitchFamily="34" charset="-120"/>
-              </a:rPr>
-              <a:t>2.3% feasible shots. Most probable outcome: BUY NOTHING — an empty portfolio.</a:t>
-            </a:r>
-            <a:endParaRPr lang="en-US" sz="1350" dirty="0"/>
-          </a:p>
-        </p:txBody>
-      </p:sp>
-      <p:sp>
-        <p:nvSpPr>
-          <p:cNvPr id="7" name="Shape 5"/>
-          <p:cNvSpPr/>
-          <p:nvPr/>
-        </p:nvSpPr>
-        <p:spPr>
-          <a:xfrm>
-            <a:off x="4443984" y="1965960"/>
-            <a:ext cx="3657600" cy="2651760"/>
-          </a:xfrm>
-          <a:prstGeom prst="roundRect">
-            <a:avLst>
-              <a:gd name="adj" fmla="val 2759"/>
-            </a:avLst>
-          </a:prstGeom>
-          <a:solidFill>
-            <a:srgbClr val="F0F4FB"/>
-          </a:solidFill>
-          <a:ln/>
-        </p:spPr>
-      </p:sp>
-      <p:sp>
-        <p:nvSpPr>
-          <p:cNvPr id="8" name="Text 6"/>
-          <p:cNvSpPr/>
-          <p:nvPr/>
-        </p:nvSpPr>
-        <p:spPr>
-          <a:xfrm>
-            <a:off x="4645152" y="2176272"/>
-            <a:ext cx="3246120" cy="502920"/>
-          </a:xfrm>
-          <a:prstGeom prst="rect">
-            <a:avLst/>
-          </a:prstGeom>
-          <a:noFill/>
-          <a:ln/>
-        </p:spPr>
-        <p:txBody>
-          <a:bodyPr wrap="square" lIns="0" tIns="0" rIns="0" bIns="0" rtlCol="0" anchor="ctr"/>
-          <a:lstStyle/>
-          <a:p>
-            <a:pPr indent="0" marL="0">
-              <a:buNone/>
-            </a:pPr>
-            <a:r>
-              <a:rPr lang="en-US" sz="1500" b="1" dirty="0">
-                <a:solidFill>
-                  <a:srgbClr val="C0392B"/>
-                </a:solidFill>
-                <a:latin typeface="Calibri" pitchFamily="34" charset="0"/>
-                <a:ea typeface="Calibri" pitchFamily="34" charset="-122"/>
-                <a:cs typeface="Calibri" pitchFamily="34" charset="-120"/>
-              </a:rPr>
-              <a:t>λ = 5 (large penalty)</a:t>
-            </a:r>
-            <a:endParaRPr lang="en-US" sz="1500" dirty="0"/>
-          </a:p>
-        </p:txBody>
-      </p:sp>
-      <p:sp>
-        <p:nvSpPr>
-          <p:cNvPr id="9" name="Text 7"/>
-          <p:cNvSpPr/>
-          <p:nvPr/>
-        </p:nvSpPr>
-        <p:spPr>
-          <a:xfrm>
-            <a:off x="4645152" y="2724912"/>
-            <a:ext cx="3246120" cy="1737360"/>
-          </a:xfrm>
-          <a:prstGeom prst="rect">
-            <a:avLst/>
-          </a:prstGeom>
-          <a:noFill/>
-          <a:ln/>
-        </p:spPr>
-        <p:txBody>
-          <a:bodyPr wrap="square" lIns="0" tIns="0" rIns="0" bIns="0" rtlCol="0" anchor="t"/>
-          <a:lstStyle/>
-          <a:p>
-            <a:pPr indent="0" marL="0">
-              <a:buNone/>
-            </a:pPr>
-            <a:r>
-              <a:rPr lang="en-US" sz="1350" dirty="0">
-                <a:solidFill>
-                  <a:srgbClr val="1A1E2E"/>
-                </a:solidFill>
-                <a:latin typeface="Calibri" pitchFamily="34" charset="0"/>
-                <a:ea typeface="Calibri" pitchFamily="34" charset="-122"/>
-                <a:cs typeface="Calibri" pitchFamily="34" charset="-120"/>
-              </a:rPr>
-              <a:t>Feasible — but market signal rides on 4.9% of each rotation angle: below realistic pulse calibration.</a:t>
-            </a:r>
-            <a:endParaRPr lang="en-US" sz="1350" dirty="0"/>
-          </a:p>
-        </p:txBody>
-      </p:sp>
-      <p:sp>
-        <p:nvSpPr>
-          <p:cNvPr id="10" name="Shape 8"/>
-          <p:cNvSpPr/>
-          <p:nvPr/>
-        </p:nvSpPr>
-        <p:spPr>
-          <a:xfrm>
-            <a:off x="8385048" y="1965960"/>
-            <a:ext cx="3657600" cy="2651760"/>
-          </a:xfrm>
-          <a:prstGeom prst="roundRect">
-            <a:avLst>
-              <a:gd name="adj" fmla="val 2759"/>
-            </a:avLst>
-          </a:prstGeom>
-          <a:solidFill>
-            <a:srgbClr val="F0F4FB"/>
-          </a:solidFill>
-          <a:ln/>
-        </p:spPr>
-      </p:sp>
-      <p:sp>
-        <p:nvSpPr>
-          <p:cNvPr id="11" name="Text 9"/>
-          <p:cNvSpPr/>
-          <p:nvPr/>
-        </p:nvSpPr>
-        <p:spPr>
-          <a:xfrm>
-            <a:off x="8586216" y="2176272"/>
-            <a:ext cx="3246120" cy="502920"/>
-          </a:xfrm>
-          <a:prstGeom prst="rect">
-            <a:avLst/>
-          </a:prstGeom>
-          <a:noFill/>
-          <a:ln/>
-        </p:spPr>
-        <p:txBody>
-          <a:bodyPr wrap="square" lIns="0" tIns="0" rIns="0" bIns="0" rtlCol="0" anchor="ctr"/>
-          <a:lstStyle/>
-          <a:p>
-            <a:pPr indent="0" marL="0">
-              <a:buNone/>
-            </a:pPr>
-            <a:r>
-              <a:rPr lang="en-US" sz="1500" b="1" dirty="0">
-                <a:solidFill>
-                  <a:srgbClr val="C0392B"/>
-                </a:solidFill>
-                <a:latin typeface="Calibri" pitchFamily="34" charset="0"/>
-                <a:ea typeface="Calibri" pitchFamily="34" charset="-122"/>
-                <a:cs typeface="Calibri" pitchFamily="34" charset="-120"/>
-              </a:rPr>
-              <a:t>DBSCAN at defaults</a:t>
-            </a:r>
-            <a:endParaRPr lang="en-US" sz="1500" dirty="0"/>
-          </a:p>
-        </p:txBody>
-      </p:sp>
-      <p:sp>
-        <p:nvSpPr>
-          <p:cNvPr id="12" name="Text 10"/>
-          <p:cNvSpPr/>
-          <p:nvPr/>
-        </p:nvSpPr>
-        <p:spPr>
-          <a:xfrm>
-            <a:off x="8586216" y="2724912"/>
-            <a:ext cx="3246120" cy="1737360"/>
-          </a:xfrm>
-          <a:prstGeom prst="rect">
-            <a:avLst/>
-          </a:prstGeom>
-          <a:noFill/>
-          <a:ln/>
-        </p:spPr>
-        <p:txBody>
-          <a:bodyPr wrap="square" lIns="0" tIns="0" rIns="0" bIns="0" rtlCol="0" anchor="t"/>
-          <a:lstStyle/>
-          <a:p>
-            <a:pPr indent="0" marL="0">
-              <a:buNone/>
-            </a:pPr>
-            <a:r>
-              <a:rPr lang="en-US" sz="1350" dirty="0">
-                <a:solidFill>
-                  <a:srgbClr val="1A1E2E"/>
-                </a:solidFill>
-                <a:latin typeface="Calibri" pitchFamily="34" charset="0"/>
-                <a:ea typeface="Calibri" pitchFamily="34" charset="-122"/>
-                <a:cs typeface="Calibri" pitchFamily="34" charset="-120"/>
-              </a:rPr>
-              <a:t>Labels ALL 100 assets as noise. No dendrogram to cut at a qubit budget. HRP: 96% purity, 0 discarded.</a:t>
-            </a:r>
-            <a:endParaRPr lang="en-US" sz="1350" dirty="0"/>
-          </a:p>
-        </p:txBody>
-      </p:sp>
-      <p:sp>
-        <p:nvSpPr>
-          <p:cNvPr id="13" name="Shape 11"/>
-          <p:cNvSpPr/>
-          <p:nvPr/>
-        </p:nvSpPr>
-        <p:spPr>
-          <a:xfrm>
-            <a:off x="502920" y="4892040"/>
-            <a:ext cx="11558016" cy="1371600"/>
-          </a:xfrm>
-          <a:prstGeom prst="roundRect">
-            <a:avLst>
-              <a:gd name="adj" fmla="val 5333"/>
-            </a:avLst>
-          </a:prstGeom>
-          <a:solidFill>
-            <a:srgbClr val="CADCFC"/>
-          </a:solidFill>
-          <a:ln/>
-        </p:spPr>
-      </p:sp>
-      <p:sp>
-        <p:nvSpPr>
-          <p:cNvPr id="14" name="Text 12"/>
-          <p:cNvSpPr/>
-          <p:nvPr/>
-        </p:nvSpPr>
-        <p:spPr>
-          <a:xfrm>
-            <a:off x="777240" y="5074920"/>
-            <a:ext cx="10972800" cy="1051560"/>
-          </a:xfrm>
-          <a:prstGeom prst="rect">
-            <a:avLst/>
-          </a:prstGeom>
-          <a:noFill/>
-          <a:ln/>
-        </p:spPr>
-        <p:txBody>
-          <a:bodyPr wrap="square" lIns="0" tIns="0" rIns="0" bIns="0" rtlCol="0" anchor="ctr"/>
-          <a:lstStyle/>
-          <a:p>
-            <a:pPr indent="0" marL="0">
-              <a:buNone/>
-            </a:pPr>
-            <a:r>
-              <a:rPr lang="en-US" sz="1450" b="1" dirty="0">
-                <a:solidFill>
-                  <a:srgbClr val="1A1E2E"/>
-                </a:solidFill>
-                <a:latin typeface="Calibri" pitchFamily="34" charset="0"/>
-                <a:ea typeface="Calibri" pitchFamily="34" charset="-122"/>
-                <a:cs typeface="Calibri" pitchFamily="34" charset="-120"/>
-              </a:rPr>
-              <a:t>The double bind, demonstrated: </a:t>
-            </a:r>
-            <a:pPr indent="0" marL="0">
-              <a:buNone/>
-            </a:pPr>
-            <a:r>
-              <a:rPr lang="en-US" sz="1450" dirty="0">
-                <a:solidFill>
-                  <a:srgbClr val="1A1E2E"/>
-                </a:solidFill>
-                <a:latin typeface="Calibri" pitchFamily="34" charset="0"/>
-                <a:ea typeface="Calibri" pitchFamily="34" charset="-122"/>
-                <a:cs typeface="Calibri" pitchFamily="34" charset="-120"/>
-              </a:rPr>
-              <a:t>no λ is right. Small λ leaks the mandate; large λ erases the market. And because the penalty couples all N assets, their formulation cannot be decomposed — whatever λ they pick, they must run one monolithic N-qubit circuit.</a:t>
-            </a:r>
-            <a:endParaRPr lang="en-US" sz="1450" dirty="0"/>
+              <a:rPr lang="en-US" sz="1250" i="1" dirty="0">
+                <a:solidFill>
+                  <a:srgbClr val="5A6478"/>
+                </a:solidFill>
+                <a:latin typeface="Calibri" pitchFamily="34" charset="0"/>
+                <a:ea typeface="Calibri" pitchFamily="34" charset="-122"/>
+                <a:cs typeface="Calibri" pitchFamily="34" charset="-120"/>
+              </a:rPr>
+              <a:t>Interactive Streamlit copilot · three tabs: Allocation · ADMM Convergence · Hardware Audit.</a:t>
+            </a:r>
+            <a:endParaRPr lang="en-US" sz="1250" dirty="0"/>
           </a:p>
         </p:txBody>
       </p:sp>
@@ -6396,42 +6591,65 @@
                 <a:ea typeface="Cambria" pitchFamily="34" charset="-122"/>
                 <a:cs typeface="Cambria" pitchFamily="34" charset="-120"/>
               </a:rPr>
-              <a:t>Hardware Audit: Real Transpiler, Real Heavy-Hex Lattice</a:t>
+              <a:t>Adversarial Benchmark: We Ran Their Stack, Correctly</a:t>
             </a:r>
             <a:endParaRPr lang="en-US" sz="3000" dirty="0"/>
           </a:p>
         </p:txBody>
       </p:sp>
-      <p:graphicFrame>
-        <p:nvGraphicFramePr>
-          <p:cNvPr id="3" name="Chart 0" descr=""/>
-          <p:cNvGraphicFramePr/>
-          <p:nvPr/>
-        </p:nvGraphicFramePr>
-        <p:xfrm>
-          <a:off x="502920" y="1325880"/>
-          <a:ext cx="6766560" cy="4480560"/>
-        </p:xfrm>
-        <a:graphic xmlns:a="http://schemas.openxmlformats.org/drawingml/2006/main">
-          <a:graphicData uri="http://schemas.openxmlformats.org/drawingml/2006/chart">
-            <c:chart xmlns:c="http://schemas.openxmlformats.org/drawingml/2006/chart" r:id="rId1"/>
-          </a:graphicData>
-        </a:graphic>
-      </p:graphicFrame>
-      <p:sp>
-        <p:nvSpPr>
-          <p:cNvPr id="4" name="Shape 1"/>
-          <p:cNvSpPr/>
-          <p:nvPr/>
-        </p:nvSpPr>
-        <p:spPr>
-          <a:xfrm>
-            <a:off x="7589520" y="1325880"/>
-            <a:ext cx="4069080" cy="4480560"/>
+      <p:sp>
+        <p:nvSpPr>
+          <p:cNvPr id="3" name="Text 1"/>
+          <p:cNvSpPr/>
+          <p:nvPr/>
+        </p:nvSpPr>
+        <p:spPr>
+          <a:xfrm>
+            <a:off x="502920" y="1188720"/>
+            <a:ext cx="11155680" cy="548640"/>
+          </a:xfrm>
+          <a:prstGeom prst="rect">
+            <a:avLst/>
+          </a:prstGeom>
+          <a:noFill/>
+          <a:ln/>
+        </p:spPr>
+        <p:txBody>
+          <a:bodyPr wrap="square" lIns="0" tIns="0" rIns="0" bIns="0" rtlCol="0" anchor="ctr"/>
+          <a:lstStyle/>
+          <a:p>
+            <a:pPr indent="0" marL="0">
+              <a:buNone/>
+            </a:pPr>
+            <a:r>
+              <a:rPr lang="en-US" sz="1400" dirty="0">
+                <a:solidFill>
+                  <a:srgbClr val="5A6478"/>
+                </a:solidFill>
+                <a:latin typeface="Calibri" pitchFamily="34" charset="0"/>
+                <a:ea typeface="Calibri" pitchFamily="34" charset="-122"/>
+                <a:cs typeface="Calibri" pitchFamily="34" charset="-120"/>
+              </a:rPr>
+              <a:t>Full-strength replication of the DBSCAN + soft-penalty-QUBO + X-mixer pipeline — encoding verified exact against brute force. Failure modes are measured, never scripted.</a:t>
+            </a:r>
+            <a:endParaRPr lang="en-US" sz="1400" dirty="0"/>
+          </a:p>
+        </p:txBody>
+      </p:sp>
+      <p:sp>
+        <p:nvSpPr>
+          <p:cNvPr id="4" name="Shape 2"/>
+          <p:cNvSpPr/>
+          <p:nvPr/>
+        </p:nvSpPr>
+        <p:spPr>
+          <a:xfrm>
+            <a:off x="502920" y="1965960"/>
+            <a:ext cx="3657600" cy="2651760"/>
           </a:xfrm>
           <a:prstGeom prst="roundRect">
             <a:avLst>
-              <a:gd name="adj" fmla="val 1798"/>
+              <a:gd name="adj" fmla="val 2759"/>
             </a:avLst>
           </a:prstGeom>
           <a:solidFill>
@@ -6442,14 +6660,14 @@
       </p:sp>
       <p:sp>
         <p:nvSpPr>
-          <p:cNvPr id="5" name="Text 2"/>
-          <p:cNvSpPr/>
-          <p:nvPr/>
-        </p:nvSpPr>
-        <p:spPr>
-          <a:xfrm>
-            <a:off x="7772400" y="1645920"/>
-            <a:ext cx="3703320" cy="868680"/>
+          <p:cNvPr id="5" name="Text 3"/>
+          <p:cNvSpPr/>
+          <p:nvPr/>
+        </p:nvSpPr>
+        <p:spPr>
+          <a:xfrm>
+            <a:off x="704088" y="2176272"/>
+            <a:ext cx="3246120" cy="502920"/>
           </a:xfrm>
           <a:prstGeom prst="rect">
             <a:avLst/>
@@ -6461,11 +6679,11 @@
           <a:bodyPr wrap="square" lIns="0" tIns="0" rIns="0" bIns="0" rtlCol="0" anchor="ctr"/>
           <a:lstStyle/>
           <a:p>
-            <a:pPr algn="ctr" indent="0" marL="0">
-              <a:buNone/>
-            </a:pPr>
-            <a:r>
-              <a:rPr lang="en-US" sz="4000" b="1" dirty="0">
+            <a:pPr indent="0" marL="0">
+              <a:buNone/>
+            </a:pPr>
+            <a:r>
+              <a:rPr lang="en-US" sz="1500" b="1" dirty="0">
                 <a:solidFill>
                   <a:srgbClr val="C0392B"/>
                 </a:solidFill>
@@ -6473,22 +6691,83 @@
                 <a:ea typeface="Calibri" pitchFamily="34" charset="-122"/>
                 <a:cs typeface="Calibri" pitchFamily="34" charset="-120"/>
               </a:rPr>
-              <a:t>14,630</a:t>
-            </a:r>
-            <a:endParaRPr lang="en-US" sz="4000" dirty="0"/>
-          </a:p>
-        </p:txBody>
-      </p:sp>
-      <p:sp>
-        <p:nvSpPr>
-          <p:cNvPr id="6" name="Text 3"/>
-          <p:cNvSpPr/>
-          <p:nvPr/>
-        </p:nvSpPr>
-        <p:spPr>
-          <a:xfrm>
-            <a:off x="7772400" y="2487168"/>
-            <a:ext cx="3703320" cy="685800"/>
+              <a:t>λ = 0.05 (small penalty)</a:t>
+            </a:r>
+            <a:endParaRPr lang="en-US" sz="1500" dirty="0"/>
+          </a:p>
+        </p:txBody>
+      </p:sp>
+      <p:sp>
+        <p:nvSpPr>
+          <p:cNvPr id="6" name="Text 4"/>
+          <p:cNvSpPr/>
+          <p:nvPr/>
+        </p:nvSpPr>
+        <p:spPr>
+          <a:xfrm>
+            <a:off x="704088" y="2724912"/>
+            <a:ext cx="3246120" cy="1737360"/>
+          </a:xfrm>
+          <a:prstGeom prst="rect">
+            <a:avLst/>
+          </a:prstGeom>
+          <a:noFill/>
+          <a:ln/>
+        </p:spPr>
+        <p:txBody>
+          <a:bodyPr wrap="square" lIns="0" tIns="0" rIns="0" bIns="0" rtlCol="0" anchor="t"/>
+          <a:lstStyle/>
+          <a:p>
+            <a:pPr indent="0" marL="0">
+              <a:buNone/>
+            </a:pPr>
+            <a:r>
+              <a:rPr lang="en-US" sz="1350" dirty="0">
+                <a:solidFill>
+                  <a:srgbClr val="1A1E2E"/>
+                </a:solidFill>
+                <a:latin typeface="Calibri" pitchFamily="34" charset="0"/>
+                <a:ea typeface="Calibri" pitchFamily="34" charset="-122"/>
+                <a:cs typeface="Calibri" pitchFamily="34" charset="-120"/>
+              </a:rPr>
+              <a:t>2.3% feasible shots. Most probable outcome: BUY NOTHING — an empty portfolio.</a:t>
+            </a:r>
+            <a:endParaRPr lang="en-US" sz="1350" dirty="0"/>
+          </a:p>
+        </p:txBody>
+      </p:sp>
+      <p:sp>
+        <p:nvSpPr>
+          <p:cNvPr id="7" name="Shape 5"/>
+          <p:cNvSpPr/>
+          <p:nvPr/>
+        </p:nvSpPr>
+        <p:spPr>
+          <a:xfrm>
+            <a:off x="4443984" y="1965960"/>
+            <a:ext cx="3657600" cy="2651760"/>
+          </a:xfrm>
+          <a:prstGeom prst="roundRect">
+            <a:avLst>
+              <a:gd name="adj" fmla="val 2759"/>
+            </a:avLst>
+          </a:prstGeom>
+          <a:solidFill>
+            <a:srgbClr val="F0F4FB"/>
+          </a:solidFill>
+          <a:ln/>
+        </p:spPr>
+      </p:sp>
+      <p:sp>
+        <p:nvSpPr>
+          <p:cNvPr id="8" name="Text 6"/>
+          <p:cNvSpPr/>
+          <p:nvPr/>
+        </p:nvSpPr>
+        <p:spPr>
+          <a:xfrm>
+            <a:off x="4645152" y="2176272"/>
+            <a:ext cx="3246120" cy="502920"/>
           </a:xfrm>
           <a:prstGeom prst="rect">
             <a:avLst/>
@@ -6500,34 +6779,95 @@
           <a:bodyPr wrap="square" lIns="0" tIns="0" rIns="0" bIns="0" rtlCol="0" anchor="ctr"/>
           <a:lstStyle/>
           <a:p>
-            <a:pPr algn="ctr" indent="0" marL="0">
-              <a:buNone/>
-            </a:pPr>
-            <a:r>
-              <a:rPr lang="en-US" sz="1250" dirty="0">
-                <a:solidFill>
-                  <a:srgbClr val="5A6478"/>
-                </a:solidFill>
-                <a:latin typeface="Calibri" pitchFamily="34" charset="0"/>
-                <a:ea typeface="Calibri" pitchFamily="34" charset="-122"/>
-                <a:cs typeface="Calibri" pitchFamily="34" charset="-120"/>
-              </a:rPr>
-              <a:t>SWAP-tax CX gates the monolithic penalty circuit pays for routing alone</a:t>
-            </a:r>
-            <a:endParaRPr lang="en-US" sz="1250" dirty="0"/>
-          </a:p>
-        </p:txBody>
-      </p:sp>
-      <p:sp>
-        <p:nvSpPr>
-          <p:cNvPr id="7" name="Text 4"/>
-          <p:cNvSpPr/>
-          <p:nvPr/>
-        </p:nvSpPr>
-        <p:spPr>
-          <a:xfrm>
-            <a:off x="7772400" y="3200400"/>
-            <a:ext cx="3703320" cy="868680"/>
+            <a:pPr indent="0" marL="0">
+              <a:buNone/>
+            </a:pPr>
+            <a:r>
+              <a:rPr lang="en-US" sz="1500" b="1" dirty="0">
+                <a:solidFill>
+                  <a:srgbClr val="C0392B"/>
+                </a:solidFill>
+                <a:latin typeface="Calibri" pitchFamily="34" charset="0"/>
+                <a:ea typeface="Calibri" pitchFamily="34" charset="-122"/>
+                <a:cs typeface="Calibri" pitchFamily="34" charset="-120"/>
+              </a:rPr>
+              <a:t>λ = 5 (large penalty)</a:t>
+            </a:r>
+            <a:endParaRPr lang="en-US" sz="1500" dirty="0"/>
+          </a:p>
+        </p:txBody>
+      </p:sp>
+      <p:sp>
+        <p:nvSpPr>
+          <p:cNvPr id="9" name="Text 7"/>
+          <p:cNvSpPr/>
+          <p:nvPr/>
+        </p:nvSpPr>
+        <p:spPr>
+          <a:xfrm>
+            <a:off x="4645152" y="2724912"/>
+            <a:ext cx="3246120" cy="1737360"/>
+          </a:xfrm>
+          <a:prstGeom prst="rect">
+            <a:avLst/>
+          </a:prstGeom>
+          <a:noFill/>
+          <a:ln/>
+        </p:spPr>
+        <p:txBody>
+          <a:bodyPr wrap="square" lIns="0" tIns="0" rIns="0" bIns="0" rtlCol="0" anchor="t"/>
+          <a:lstStyle/>
+          <a:p>
+            <a:pPr indent="0" marL="0">
+              <a:buNone/>
+            </a:pPr>
+            <a:r>
+              <a:rPr lang="en-US" sz="1350" dirty="0">
+                <a:solidFill>
+                  <a:srgbClr val="1A1E2E"/>
+                </a:solidFill>
+                <a:latin typeface="Calibri" pitchFamily="34" charset="0"/>
+                <a:ea typeface="Calibri" pitchFamily="34" charset="-122"/>
+                <a:cs typeface="Calibri" pitchFamily="34" charset="-120"/>
+              </a:rPr>
+              <a:t>Feasible — but market signal rides on 4.9% of each rotation angle: below realistic pulse calibration.</a:t>
+            </a:r>
+            <a:endParaRPr lang="en-US" sz="1350" dirty="0"/>
+          </a:p>
+        </p:txBody>
+      </p:sp>
+      <p:sp>
+        <p:nvSpPr>
+          <p:cNvPr id="10" name="Shape 8"/>
+          <p:cNvSpPr/>
+          <p:nvPr/>
+        </p:nvSpPr>
+        <p:spPr>
+          <a:xfrm>
+            <a:off x="8385048" y="1965960"/>
+            <a:ext cx="3657600" cy="2651760"/>
+          </a:xfrm>
+          <a:prstGeom prst="roundRect">
+            <a:avLst>
+              <a:gd name="adj" fmla="val 2759"/>
+            </a:avLst>
+          </a:prstGeom>
+          <a:solidFill>
+            <a:srgbClr val="F0F4FB"/>
+          </a:solidFill>
+          <a:ln/>
+        </p:spPr>
+      </p:sp>
+      <p:sp>
+        <p:nvSpPr>
+          <p:cNvPr id="11" name="Text 9"/>
+          <p:cNvSpPr/>
+          <p:nvPr/>
+        </p:nvSpPr>
+        <p:spPr>
+          <a:xfrm>
+            <a:off x="8586216" y="2176272"/>
+            <a:ext cx="3246120" cy="502920"/>
           </a:xfrm>
           <a:prstGeom prst="rect">
             <a:avLst/>
@@ -6539,11 +6879,11 @@
           <a:bodyPr wrap="square" lIns="0" tIns="0" rIns="0" bIns="0" rtlCol="0" anchor="ctr"/>
           <a:lstStyle/>
           <a:p>
-            <a:pPr algn="ctr" indent="0" marL="0">
-              <a:buNone/>
-            </a:pPr>
-            <a:r>
-              <a:rPr lang="en-US" sz="4000" b="1" dirty="0">
+            <a:pPr indent="0" marL="0">
+              <a:buNone/>
+            </a:pPr>
+            <a:r>
+              <a:rPr lang="en-US" sz="1500" b="1" dirty="0">
                 <a:solidFill>
                   <a:srgbClr val="C0392B"/>
                 </a:solidFill>
@@ -6551,22 +6891,83 @@
                 <a:ea typeface="Calibri" pitchFamily="34" charset="-122"/>
                 <a:cs typeface="Calibri" pitchFamily="34" charset="-120"/>
               </a:rPr>
-              <a:t>14×</a:t>
-            </a:r>
-            <a:endParaRPr lang="en-US" sz="4000" dirty="0"/>
-          </a:p>
-        </p:txBody>
-      </p:sp>
-      <p:sp>
-        <p:nvSpPr>
-          <p:cNvPr id="8" name="Text 5"/>
-          <p:cNvSpPr/>
-          <p:nvPr/>
-        </p:nvSpPr>
-        <p:spPr>
-          <a:xfrm>
-            <a:off x="7772400" y="4041648"/>
-            <a:ext cx="3703320" cy="685800"/>
+              <a:t>DBSCAN at defaults</a:t>
+            </a:r>
+            <a:endParaRPr lang="en-US" sz="1500" dirty="0"/>
+          </a:p>
+        </p:txBody>
+      </p:sp>
+      <p:sp>
+        <p:nvSpPr>
+          <p:cNvPr id="12" name="Text 10"/>
+          <p:cNvSpPr/>
+          <p:nvPr/>
+        </p:nvSpPr>
+        <p:spPr>
+          <a:xfrm>
+            <a:off x="8586216" y="2724912"/>
+            <a:ext cx="3246120" cy="1737360"/>
+          </a:xfrm>
+          <a:prstGeom prst="rect">
+            <a:avLst/>
+          </a:prstGeom>
+          <a:noFill/>
+          <a:ln/>
+        </p:spPr>
+        <p:txBody>
+          <a:bodyPr wrap="square" lIns="0" tIns="0" rIns="0" bIns="0" rtlCol="0" anchor="t"/>
+          <a:lstStyle/>
+          <a:p>
+            <a:pPr indent="0" marL="0">
+              <a:buNone/>
+            </a:pPr>
+            <a:r>
+              <a:rPr lang="en-US" sz="1350" dirty="0">
+                <a:solidFill>
+                  <a:srgbClr val="1A1E2E"/>
+                </a:solidFill>
+                <a:latin typeface="Calibri" pitchFamily="34" charset="0"/>
+                <a:ea typeface="Calibri" pitchFamily="34" charset="-122"/>
+                <a:cs typeface="Calibri" pitchFamily="34" charset="-120"/>
+              </a:rPr>
+              <a:t>Labels ALL 100 assets as noise. No dendrogram to cut at a qubit budget. HRP: 96% purity, 0 discarded.</a:t>
+            </a:r>
+            <a:endParaRPr lang="en-US" sz="1350" dirty="0"/>
+          </a:p>
+        </p:txBody>
+      </p:sp>
+      <p:sp>
+        <p:nvSpPr>
+          <p:cNvPr id="13" name="Shape 11"/>
+          <p:cNvSpPr/>
+          <p:nvPr/>
+        </p:nvSpPr>
+        <p:spPr>
+          <a:xfrm>
+            <a:off x="502920" y="4892040"/>
+            <a:ext cx="11558016" cy="1371600"/>
+          </a:xfrm>
+          <a:prstGeom prst="roundRect">
+            <a:avLst>
+              <a:gd name="adj" fmla="val 5333"/>
+            </a:avLst>
+          </a:prstGeom>
+          <a:solidFill>
+            <a:srgbClr val="CADCFC"/>
+          </a:solidFill>
+          <a:ln/>
+        </p:spPr>
+      </p:sp>
+      <p:sp>
+        <p:nvSpPr>
+          <p:cNvPr id="14" name="Text 12"/>
+          <p:cNvSpPr/>
+          <p:nvPr/>
+        </p:nvSpPr>
+        <p:spPr>
+          <a:xfrm>
+            <a:off x="777240" y="5074920"/>
+            <a:ext cx="10972800" cy="1051560"/>
           </a:xfrm>
           <a:prstGeom prst="rect">
             <a:avLst/>
@@ -6578,60 +6979,35 @@
           <a:bodyPr wrap="square" lIns="0" tIns="0" rIns="0" bIns="0" rtlCol="0" anchor="ctr"/>
           <a:lstStyle/>
           <a:p>
-            <a:pPr algn="ctr" indent="0" marL="0">
-              <a:buNone/>
-            </a:pPr>
-            <a:r>
-              <a:rPr lang="en-US" sz="1250" dirty="0">
-                <a:solidFill>
-                  <a:srgbClr val="5A6478"/>
-                </a:solidFill>
-                <a:latin typeface="Calibri" pitchFamily="34" charset="0"/>
-                <a:ea typeface="Calibri" pitchFamily="34" charset="-122"/>
-                <a:cs typeface="Calibri" pitchFamily="34" charset="-120"/>
-              </a:rPr>
-              <a:t>more noise exposure than OMEGA's largest circuit — same N=100 problem</a:t>
-            </a:r>
-            <a:endParaRPr lang="en-US" sz="1250" dirty="0"/>
-          </a:p>
-        </p:txBody>
-      </p:sp>
-      <p:sp>
-        <p:nvSpPr>
-          <p:cNvPr id="9" name="Text 6"/>
-          <p:cNvSpPr/>
-          <p:nvPr/>
-        </p:nvSpPr>
-        <p:spPr>
-          <a:xfrm>
-            <a:off x="502920" y="5897880"/>
-            <a:ext cx="11155680" cy="594360"/>
-          </a:xfrm>
-          <a:prstGeom prst="rect">
-            <a:avLst/>
-          </a:prstGeom>
-          <a:noFill/>
-          <a:ln/>
-        </p:spPr>
-        <p:txBody>
-          <a:bodyPr wrap="square" lIns="0" tIns="0" rIns="0" bIns="0" rtlCol="0" anchor="ctr"/>
-          <a:lstStyle/>
-          <a:p>
-            <a:pPr indent="0" marL="0">
-              <a:buNone/>
-            </a:pPr>
-            <a:r>
-              <a:rPr lang="en-US" sz="1300" i="1" dirty="0">
-                <a:solidFill>
-                  <a:srgbClr val="5A6478"/>
-                </a:solidFill>
-                <a:latin typeface="Calibri" pitchFamily="34" charset="0"/>
-                <a:ea typeface="Calibri" pitchFamily="34" charset="-122"/>
-                <a:cs typeface="Calibri" pitchFamily="34" charset="-120"/>
-              </a:rPr>
-              <a:t>At matched size their circuit is cheaper (530 vs 1,735) — we show it. The point is architectural: they can never run small; we never need to run big.</a:t>
-            </a:r>
-            <a:endParaRPr lang="en-US" sz="1300" dirty="0"/>
+            <a:pPr indent="0" marL="0">
+              <a:buNone/>
+            </a:pPr>
+            <a:r>
+              <a:rPr lang="en-US" sz="1450" b="1" dirty="0">
+                <a:solidFill>
+                  <a:srgbClr val="1A1E2E"/>
+                </a:solidFill>
+                <a:latin typeface="Calibri" pitchFamily="34" charset="0"/>
+                <a:ea typeface="Calibri" pitchFamily="34" charset="-122"/>
+                <a:cs typeface="Calibri" pitchFamily="34" charset="-120"/>
+              </a:rPr>
+              <a:t>The double bind, demonstrated: </a:t>
+            </a:r>
+            <a:pPr indent="0" marL="0">
+              <a:buNone/>
+            </a:pPr>
+            <a:r>
+              <a:rPr lang="en-US" sz="1450" dirty="0">
+                <a:solidFill>
+                  <a:srgbClr val="1A1E2E"/>
+                </a:solidFill>
+                <a:latin typeface="Calibri" pitchFamily="34" charset="0"/>
+                <a:ea typeface="Calibri" pitchFamily="34" charset="-122"/>
+                <a:cs typeface="Calibri" pitchFamily="34" charset="-120"/>
+              </a:rPr>
+              <a:t>no λ is right. Small λ leaks the mandate; large λ erases the market. And because the penalty couples all N assets, their formulation cannot be decomposed — whatever λ they pick, they must run one monolithic N-qubit circuit.</a:t>
+            </a:r>
+            <a:endParaRPr lang="en-US" sz="1450" dirty="0"/>
           </a:p>
         </p:txBody>
       </p:sp>

</xml_diff>

<commit_message>
Add per-slide speaker notes to the deck (script + timing per slide)
</commit_message>
<xml_diff>
--- a/presentation/WISER_Vanguard_OMEGA.pptx
+++ b/presentation/WISER_Vanguard_OMEGA.pptx
@@ -785,7 +785,7 @@
           <a:p>
             <a:r>
               <a:rPr lang="en-US" dirty="0"/>
-              <a:t/>
+              <a:t>[~15s] Hi, I'm Hastika. My project builds a quantum-classical pipeline for multi-asset portfolio construction. The whole idea: enforce the portfolio rules through the PHYSICS of a quantum circuit, not a tunable penalty. Take a breath, then next slide.</a:t>
             </a:r>
             <a:endParaRPr lang="en-US" dirty="0"/>
           </a:p>
@@ -873,7 +873,7 @@
           <a:p>
             <a:r>
               <a:rPr lang="en-US" dirty="0"/>
-              <a:t/>
+              <a:t>[~45s — the payoff] On a real quantum-hardware layout: my biggest circuit needs about 1,700 two-qubit gates. The penalty method's REQUIRED circuit needs over 24,000 — fourteen times more. On today's noisy hardware that's the difference between usable and unusable. The reason is structural: their penalty ties all the assets together, so they can't break the problem into pieces. Mine can. (If a judge pushes: yes, at equal size their circuit is cheaper — I show that honestly — the advantage is architectural.)</a:t>
             </a:r>
             <a:endParaRPr lang="en-US" dirty="0"/>
           </a:p>
@@ -961,7 +961,7 @@
           <a:p>
             <a:r>
               <a:rPr lang="en-US" dirty="0"/>
-              <a:t/>
+              <a:t>[~30s] To be clear on scope: this is built for the NISQ hardware we actually have — every circuit stays small enough to run on a real chip, and I packaged the classical core as a deployable engine with compliance checks and audit trails. The roadmap: run on a real quantum processor, scale to sizes where classical breaks down, and plug in a professional risk model. Today the advantage is structural — a guarantee plus a hardware-ready design.</a:t>
             </a:r>
             <a:endParaRPr lang="en-US" dirty="0"/>
           </a:p>
@@ -1049,7 +1049,7 @@
           <a:p>
             <a:r>
               <a:rPr lang="en-US" dirty="0"/>
-              <a:t/>
+              <a:t>[~15s] In one line: feasibility as a symmetry, not a penalty — and an architecture that stays hardware-ready as these problems grow. Everything's measured and in the repo. Thank you. Then STOP talking — smile, and wait for the judge's question.</a:t>
             </a:r>
             <a:endParaRPr lang="en-US" dirty="0"/>
           </a:p>
@@ -1137,7 +1137,7 @@
           <a:p>
             <a:r>
               <a:rPr lang="en-US" dirty="0"/>
-              <a:t/>
+              <a:t>[~35s] The challenge: pick EXACTLY K assets from many, allocate money across them, and never break hard rules — position limits, how many assets you hold, sector caps. The usual quantum method turns 'exactly K' into a penalty you tune with a knob called lambda. The problem: a penalty only ENCOURAGES the rule — set it too low, the circuit ignores it; too high, it drowns out the market signal. (Don't read the math box — just gesture to it as 'a real, hard optimization problem'.)</a:t>
             </a:r>
             <a:endParaRPr lang="en-US" dirty="0"/>
           </a:p>
@@ -1225,7 +1225,7 @@
           <a:p>
             <a:r>
               <a:rPr lang="en-US" dirty="0"/>
-              <a:t/>
+              <a:t>[~30s] To scale this to 100 assets, four pieces work together. HRP splits the universe into small clusters. ADMM coordinates the classical and quantum layers. A classical convex optimizer handles the money allocation. And the quantum step does the asset selection. Point at the four cards — don't read them word for word.</a:t>
             </a:r>
             <a:endParaRPr lang="en-US" dirty="0"/>
           </a:p>
@@ -1313,7 +1313,7 @@
           <a:p>
             <a:r>
               <a:rPr lang="en-US" dirty="0"/>
-              <a:t/>
+              <a:t>[~45s — THE most important slide, say it slowly] I remove the penalty completely. I start the circuit in a special state, and use gates that all conserve the number of selected assets. So the circuit PHYSICALLY CANNOT produce a portfolio with the wrong number of assets. I measured the probability of an illegal result at ten-to-the-minus-33 — essentially zero. So compliance becomes a mathematical guarantee, not a knob you hope you tuned right.</a:t>
             </a:r>
             <a:endParaRPr lang="en-US" dirty="0"/>
           </a:p>
@@ -1401,7 +1401,7 @@
           <a:p>
             <a:r>
               <a:rPr lang="en-US" dirty="0"/>
-              <a:t/>
+              <a:t>[FLASH ~10s, or SKIP if running long] One quick point: the quantum circuit is compiled to MATCH the real hardware layout, so it runs without extra routing gates. That's it — move on. If you're tight on time, skip this slide entirely; it's a bonus detail.</a:t>
             </a:r>
             <a:endParaRPr lang="en-US" dirty="0"/>
           </a:p>
@@ -1489,7 +1489,7 @@
           <a:p>
             <a:r>
               <a:rPr lang="en-US" dirty="0"/>
-              <a:t/>
+              <a:t>[~15s — quick] The pipeline also handles four real investor goals — growth, income, drawdown control, and cost — and each one has a MEASURED effect. Don't read all four out; just say 'four tunable goals, all with measured effects' and move on.</a:t>
             </a:r>
             <a:endParaRPr lang="en-US" dirty="0"/>
           </a:p>
@@ -1577,7 +1577,7 @@
           <a:p>
             <a:r>
               <a:rPr lang="en-US" dirty="0"/>
-              <a:t/>
+              <a:t>[~40s] The results — all measured and reproducible. Zero hard-rule breaches, guaranteed by design. A Sharpe ratio of 0.47 net of costs. And an approximation ratio of ONE-POINT-ZERO against a certified optimal solution — it found the best possible answer at the sizes I tested. I validated against exhaustive search, MIQP, and simulated annealing.</a:t>
             </a:r>
             <a:endParaRPr lang="en-US" dirty="0"/>
           </a:p>
@@ -1665,7 +1665,7 @@
           <a:p>
             <a:r>
               <a:rPr lang="en-US" dirty="0"/>
-              <a:t/>
+              <a:t>[~15s — this is your DEMO] And here's the copilot itself, running on 41 real ETFs. You can see zero breaches up top, the selected holdings with real tickers, and the goal sliders on the left. It's fully interactive — I'm showing it as a screenshot so we stay on time. (Only flip to the live app if it's already open AND you feel confident.)</a:t>
             </a:r>
             <a:endParaRPr lang="en-US" dirty="0"/>
           </a:p>
@@ -1753,7 +1753,7 @@
           <a:p>
             <a:r>
               <a:rPr lang="en-US" dirty="0"/>
-              <a:t/>
+              <a:t>[FLASH ~15s, or SKIP if running long] I also built the standard penalty approach at full strength and measured how it fails: at low penalty it picks nothing — an empty portfolio; at high penalty it drowns the market signal. One line, then move to the hardware slide. Skip if you're tight on time.</a:t>
             </a:r>
             <a:endParaRPr lang="en-US" dirty="0"/>
           </a:p>

</xml_diff>